<commit_message>
added predictive power for medical test
</commit_message>
<xml_diff>
--- a/Precision_Recall_ROC_Confusion.pptx
+++ b/Precision_Recall_ROC_Confusion.pptx
@@ -5,7 +5,7 @@
     <p:sldMasterId id="2147483648" r:id="rId1"/>
   </p:sldMasterIdLst>
   <p:notesMasterIdLst>
-    <p:notesMasterId r:id="rId7"/>
+    <p:notesMasterId r:id="rId8"/>
   </p:notesMasterIdLst>
   <p:sldIdLst>
     <p:sldId id="333" r:id="rId2"/>
@@ -13,6 +13,7 @@
     <p:sldId id="342" r:id="rId4"/>
     <p:sldId id="344" r:id="rId5"/>
     <p:sldId id="343" r:id="rId6"/>
+    <p:sldId id="346" r:id="rId7"/>
   </p:sldIdLst>
   <p:sldSz cx="12192000" cy="6858000"/>
   <p:notesSz cx="6858000" cy="9144000"/>
@@ -971,7 +972,7 @@
           <a:p>
             <a:fld id="{AC91B679-F1BC-D040-817F-A2F595AB9D9A}" type="datetimeFigureOut">
               <a:rPr lang="en-US" smtClean="0"/>
-              <a:t>10/31/19</a:t>
+              <a:t>1/3/21</a:t>
             </a:fld>
             <a:endParaRPr lang="en-US"/>
           </a:p>
@@ -1821,7 +1822,7 @@
           <a:p>
             <a:fld id="{F1DC6890-0266-1140-AA82-3B7AF23274A1}" type="datetimeFigureOut">
               <a:rPr lang="en-US" smtClean="0"/>
-              <a:t>10/31/19</a:t>
+              <a:t>1/3/21</a:t>
             </a:fld>
             <a:endParaRPr lang="en-US"/>
           </a:p>
@@ -2019,7 +2020,7 @@
           <a:p>
             <a:fld id="{F1DC6890-0266-1140-AA82-3B7AF23274A1}" type="datetimeFigureOut">
               <a:rPr lang="en-US" smtClean="0"/>
-              <a:t>10/31/19</a:t>
+              <a:t>1/3/21</a:t>
             </a:fld>
             <a:endParaRPr lang="en-US"/>
           </a:p>
@@ -2227,7 +2228,7 @@
           <a:p>
             <a:fld id="{F1DC6890-0266-1140-AA82-3B7AF23274A1}" type="datetimeFigureOut">
               <a:rPr lang="en-US" smtClean="0"/>
-              <a:t>10/31/19</a:t>
+              <a:t>1/3/21</a:t>
             </a:fld>
             <a:endParaRPr lang="en-US"/>
           </a:p>
@@ -2425,7 +2426,7 @@
           <a:p>
             <a:fld id="{F1DC6890-0266-1140-AA82-3B7AF23274A1}" type="datetimeFigureOut">
               <a:rPr lang="en-US" smtClean="0"/>
-              <a:t>10/31/19</a:t>
+              <a:t>1/3/21</a:t>
             </a:fld>
             <a:endParaRPr lang="en-US"/>
           </a:p>
@@ -2700,7 +2701,7 @@
           <a:p>
             <a:fld id="{F1DC6890-0266-1140-AA82-3B7AF23274A1}" type="datetimeFigureOut">
               <a:rPr lang="en-US" smtClean="0"/>
-              <a:t>10/31/19</a:t>
+              <a:t>1/3/21</a:t>
             </a:fld>
             <a:endParaRPr lang="en-US"/>
           </a:p>
@@ -2965,7 +2966,7 @@
           <a:p>
             <a:fld id="{F1DC6890-0266-1140-AA82-3B7AF23274A1}" type="datetimeFigureOut">
               <a:rPr lang="en-US" smtClean="0"/>
-              <a:t>10/31/19</a:t>
+              <a:t>1/3/21</a:t>
             </a:fld>
             <a:endParaRPr lang="en-US"/>
           </a:p>
@@ -3377,7 +3378,7 @@
           <a:p>
             <a:fld id="{F1DC6890-0266-1140-AA82-3B7AF23274A1}" type="datetimeFigureOut">
               <a:rPr lang="en-US" smtClean="0"/>
-              <a:t>10/31/19</a:t>
+              <a:t>1/3/21</a:t>
             </a:fld>
             <a:endParaRPr lang="en-US"/>
           </a:p>
@@ -3518,7 +3519,7 @@
           <a:p>
             <a:fld id="{F1DC6890-0266-1140-AA82-3B7AF23274A1}" type="datetimeFigureOut">
               <a:rPr lang="en-US" smtClean="0"/>
-              <a:t>10/31/19</a:t>
+              <a:t>1/3/21</a:t>
             </a:fld>
             <a:endParaRPr lang="en-US"/>
           </a:p>
@@ -3631,7 +3632,7 @@
           <a:p>
             <a:fld id="{F1DC6890-0266-1140-AA82-3B7AF23274A1}" type="datetimeFigureOut">
               <a:rPr lang="en-US" smtClean="0"/>
-              <a:t>10/31/19</a:t>
+              <a:t>1/3/21</a:t>
             </a:fld>
             <a:endParaRPr lang="en-US"/>
           </a:p>
@@ -3942,7 +3943,7 @@
           <a:p>
             <a:fld id="{F1DC6890-0266-1140-AA82-3B7AF23274A1}" type="datetimeFigureOut">
               <a:rPr lang="en-US" smtClean="0"/>
-              <a:t>10/31/19</a:t>
+              <a:t>1/3/21</a:t>
             </a:fld>
             <a:endParaRPr lang="en-US"/>
           </a:p>
@@ -4230,7 +4231,7 @@
           <a:p>
             <a:fld id="{F1DC6890-0266-1140-AA82-3B7AF23274A1}" type="datetimeFigureOut">
               <a:rPr lang="en-US" smtClean="0"/>
-              <a:t>10/31/19</a:t>
+              <a:t>1/3/21</a:t>
             </a:fld>
             <a:endParaRPr lang="en-US"/>
           </a:p>
@@ -4471,7 +4472,7 @@
           <a:p>
             <a:fld id="{F1DC6890-0266-1140-AA82-3B7AF23274A1}" type="datetimeFigureOut">
               <a:rPr lang="en-US" smtClean="0"/>
-              <a:t>10/31/19</a:t>
+              <a:t>1/3/21</a:t>
             </a:fld>
             <a:endParaRPr lang="en-US"/>
           </a:p>
@@ -4923,9 +4924,9 @@
               <a:buNone/>
             </a:pPr>
             <a:r>
-              <a:rPr lang="en-US" sz="3200" b="1" i="0" u="none" strike="noStrike" cap="none" dirty="0">
+              <a:rPr lang="en-US" sz="2800" b="1" i="0" u="none" strike="noStrike" cap="none" dirty="0">
                 <a:solidFill>
-                  <a:schemeClr val="dk1"/>
+                  <a:schemeClr val="accent2"/>
                 </a:solidFill>
                 <a:latin typeface="Calibri"/>
                 <a:ea typeface="Calibri"/>
@@ -4934,7 +4935,11 @@
               </a:rPr>
               <a:t>ROC Curve &amp; Precision-Recall Curve</a:t>
             </a:r>
-            <a:endParaRPr dirty="0"/>
+            <a:endParaRPr sz="2800" dirty="0">
+              <a:solidFill>
+                <a:schemeClr val="accent2"/>
+              </a:solidFill>
+            </a:endParaRPr>
           </a:p>
           <a:p>
             <a:pPr marL="0" marR="0" lvl="0" indent="0" algn="l" rtl="0">
@@ -4946,7 +4951,7 @@
               </a:spcAft>
               <a:buNone/>
             </a:pPr>
-            <a:endParaRPr sz="1000" dirty="0">
+            <a:endParaRPr sz="800" dirty="0">
               <a:solidFill>
                 <a:schemeClr val="dk1"/>
               </a:solidFill>
@@ -4967,7 +4972,7 @@
               <a:buNone/>
             </a:pPr>
             <a:r>
-              <a:rPr lang="en-US" sz="1800" dirty="0">
+              <a:rPr lang="en-US" sz="1600" dirty="0">
                 <a:solidFill>
                   <a:schemeClr val="dk1"/>
                 </a:solidFill>
@@ -4979,7 +4984,7 @@
               <a:t>Receiver Operating Characteristic (</a:t>
             </a:r>
             <a:r>
-              <a:rPr lang="en-US" sz="1800" b="1" dirty="0">
+              <a:rPr lang="en-US" sz="1600" b="1" dirty="0">
                 <a:solidFill>
                   <a:srgbClr val="0070C0"/>
                 </a:solidFill>
@@ -4991,7 +4996,7 @@
               <a:t>ROC</a:t>
             </a:r>
             <a:r>
-              <a:rPr lang="en-US" sz="1800" dirty="0">
+              <a:rPr lang="en-US" sz="1600" dirty="0">
                 <a:solidFill>
                   <a:schemeClr val="dk1"/>
                 </a:solidFill>
@@ -5013,7 +5018,7 @@
               </a:spcAft>
               <a:buNone/>
             </a:pPr>
-            <a:endParaRPr lang="en-US" sz="1000" dirty="0">
+            <a:endParaRPr lang="en-US" sz="800" dirty="0">
               <a:solidFill>
                 <a:schemeClr val="dk1"/>
               </a:solidFill>
@@ -5033,7 +5038,7 @@
               <a:buNone/>
             </a:pPr>
             <a:r>
-              <a:rPr lang="en-US" dirty="0">
+              <a:rPr lang="en-US" sz="1600" dirty="0">
                 <a:solidFill>
                   <a:schemeClr val="dk1"/>
                 </a:solidFill>
@@ -5044,7 +5049,7 @@
               <a:t>    </a:t>
             </a:r>
             <a:r>
-              <a:rPr lang="en-US" b="1" dirty="0">
+              <a:rPr lang="en-US" sz="1600" b="1" dirty="0">
                 <a:solidFill>
                   <a:srgbClr val="0070C0"/>
                 </a:solidFill>
@@ -5055,7 +5060,7 @@
               <a:t>True Positive Rate (TPR)</a:t>
             </a:r>
             <a:r>
-              <a:rPr lang="en-US" dirty="0">
+              <a:rPr lang="en-US" sz="1600" dirty="0">
                 <a:solidFill>
                   <a:schemeClr val="dk1"/>
                 </a:solidFill>
@@ -5066,7 +5071,7 @@
               <a:t>   vs   </a:t>
             </a:r>
             <a:r>
-              <a:rPr lang="en-US" b="1" dirty="0">
+              <a:rPr lang="en-US" sz="1600" b="1" dirty="0">
                 <a:solidFill>
                   <a:srgbClr val="0070C0"/>
                 </a:solidFill>
@@ -5080,7 +5085,7 @@
           <a:p>
             <a:pPr lvl="0"/>
             <a:r>
-              <a:rPr lang="en-US" b="1" dirty="0">
+              <a:rPr lang="en-US" sz="1600" b="1" dirty="0">
                 <a:solidFill>
                   <a:srgbClr val="0070C0"/>
                 </a:solidFill>
@@ -5091,7 +5096,7 @@
               <a:t>                            </a:t>
             </a:r>
             <a:r>
-              <a:rPr lang="en-US" dirty="0">
+              <a:rPr lang="en-US" sz="1600" dirty="0">
                 <a:solidFill>
                   <a:schemeClr val="dk1"/>
                 </a:solidFill>
@@ -5112,7 +5117,7 @@
               </a:spcAft>
               <a:buNone/>
             </a:pPr>
-            <a:endParaRPr sz="1800" dirty="0">
+            <a:endParaRPr sz="800" dirty="0">
               <a:solidFill>
                 <a:schemeClr val="dk1"/>
               </a:solidFill>
@@ -5124,7 +5129,7 @@
           </a:p>
           <a:p>
             <a:r>
-              <a:rPr lang="en-US" dirty="0">
+              <a:rPr lang="en-US" sz="1600" dirty="0">
                 <a:solidFill>
                   <a:schemeClr val="dk1"/>
                 </a:solidFill>
@@ -5132,12 +5137,21 @@
                 <a:cs typeface="Calibri"/>
                 <a:sym typeface="Calibri"/>
               </a:rPr>
-              <a:t>ROC curve was first developed by radar engineers during World War II </a:t>
-            </a:r>
-          </a:p>
-          <a:p>
-            <a:r>
-              <a:rPr lang="en-US" dirty="0">
+              <a:t>ROC curve was first developed by radar engineers during </a:t>
+            </a:r>
+            <a:r>
+              <a:rPr lang="en-US" sz="1600" b="1" dirty="0">
+                <a:solidFill>
+                  <a:srgbClr val="0070C0"/>
+                </a:solidFill>
+                <a:ea typeface="Calibri"/>
+                <a:cs typeface="Calibri"/>
+                <a:sym typeface="Calibri"/>
+              </a:rPr>
+              <a:t>World War II</a:t>
+            </a:r>
+            <a:r>
+              <a:rPr lang="en-US" sz="1600" dirty="0">
                 <a:solidFill>
                   <a:schemeClr val="dk1"/>
                 </a:solidFill>
@@ -5145,13 +5159,26 @@
                 <a:cs typeface="Calibri"/>
                 <a:sym typeface="Calibri"/>
               </a:rPr>
+              <a:t> </a:t>
+            </a:r>
+          </a:p>
+          <a:p>
+            <a:r>
+              <a:rPr lang="en-US" sz="1600" dirty="0">
+                <a:solidFill>
+                  <a:schemeClr val="dk1"/>
+                </a:solidFill>
+                <a:ea typeface="Calibri"/>
+                <a:cs typeface="Calibri"/>
+                <a:sym typeface="Calibri"/>
+              </a:rPr>
               <a:t>for detecting enemy objects.</a:t>
             </a:r>
           </a:p>
           <a:p>
             <a:pPr lvl="0"/>
             <a:r>
-              <a:rPr lang="en-US" dirty="0">
+              <a:rPr lang="en-US" sz="1600" dirty="0">
                 <a:solidFill>
                   <a:schemeClr val="dk1"/>
                 </a:solidFill>
@@ -5160,10 +5187,22 @@
                 <a:cs typeface="Calibri"/>
                 <a:sym typeface="Calibri"/>
               </a:rPr>
-              <a:t>    </a:t>
-            </a:r>
-            <a:r>
-              <a:rPr lang="en-US" sz="1800" dirty="0">
+              <a:t>    TPR  = REC = </a:t>
+            </a:r>
+            <a:r>
+              <a:rPr lang="en-US" sz="1600" b="1" dirty="0">
+                <a:solidFill>
+                  <a:srgbClr val="0070C0"/>
+                </a:solidFill>
+                <a:latin typeface="Calibri"/>
+                <a:ea typeface="Calibri"/>
+                <a:cs typeface="Calibri"/>
+                <a:sym typeface="Calibri"/>
+              </a:rPr>
+              <a:t>Recall or Sensitivity</a:t>
+            </a:r>
+            <a:r>
+              <a:rPr lang="en-US" sz="1600" dirty="0">
                 <a:solidFill>
                   <a:schemeClr val="dk1"/>
                 </a:solidFill>
@@ -5172,10 +5211,50 @@
                 <a:cs typeface="Calibri"/>
                 <a:sym typeface="Calibri"/>
               </a:rPr>
-              <a:t>TPR  = REC = </a:t>
-            </a:r>
-            <a:r>
-              <a:rPr lang="en-US" sz="1800" b="1" dirty="0">
+              <a:t>  =  </a:t>
+            </a:r>
+            <a:r>
+              <a:rPr lang="en-US" sz="1600" dirty="0">
+                <a:solidFill>
+                  <a:schemeClr val="dk1"/>
+                </a:solidFill>
+                <a:ea typeface="Calibri"/>
+                <a:cs typeface="Calibri"/>
+                <a:sym typeface="Calibri"/>
+              </a:rPr>
+              <a:t>TP/P  =  TP / (TP + FN) </a:t>
+            </a:r>
+          </a:p>
+          <a:p>
+            <a:pPr lvl="0"/>
+            <a:r>
+              <a:rPr lang="en-US" sz="1600" dirty="0">
+                <a:solidFill>
+                  <a:srgbClr val="00B050"/>
+                </a:solidFill>
+                <a:ea typeface="Calibri"/>
+                <a:cs typeface="Calibri"/>
+                <a:sym typeface="Calibri"/>
+              </a:rPr>
+              <a:t>                    ( planes classified as planes / all planes' events)</a:t>
+            </a:r>
+          </a:p>
+          <a:p>
+            <a:pPr lvl="0"/>
+            <a:r>
+              <a:rPr lang="en-US" sz="1600" dirty="0">
+                <a:solidFill>
+                  <a:schemeClr val="dk1"/>
+                </a:solidFill>
+                <a:latin typeface="Calibri"/>
+                <a:ea typeface="Calibri"/>
+                <a:cs typeface="Calibri"/>
+                <a:sym typeface="Calibri"/>
+              </a:rPr>
+              <a:t>    FPR = </a:t>
+            </a:r>
+            <a:r>
+              <a:rPr lang="en-US" sz="1600" b="1" dirty="0">
                 <a:solidFill>
                   <a:srgbClr val="0070C0"/>
                 </a:solidFill>
@@ -5184,10 +5263,10 @@
                 <a:cs typeface="Calibri"/>
                 <a:sym typeface="Calibri"/>
               </a:rPr>
-              <a:t>Recall or Sensitivity</a:t>
-            </a:r>
-            <a:r>
-              <a:rPr lang="en-US" sz="1800" dirty="0">
+              <a:t>False Positive Rate</a:t>
+            </a:r>
+            <a:r>
+              <a:rPr lang="en-US" sz="1600" dirty="0">
                 <a:solidFill>
                   <a:schemeClr val="dk1"/>
                 </a:solidFill>
@@ -5196,10 +5275,22 @@
                 <a:cs typeface="Calibri"/>
                 <a:sym typeface="Calibri"/>
               </a:rPr>
-              <a:t> = </a:t>
-            </a:r>
-            <a:r>
-              <a:rPr lang="en-US" dirty="0">
+              <a:t> =</a:t>
+            </a:r>
+            <a:r>
+              <a:rPr lang="en-US" sz="1600" b="1" dirty="0">
+                <a:solidFill>
+                  <a:srgbClr val="0070C0"/>
+                </a:solidFill>
+                <a:latin typeface="Calibri"/>
+                <a:ea typeface="Calibri"/>
+                <a:cs typeface="Calibri"/>
+                <a:sym typeface="Calibri"/>
+              </a:rPr>
+              <a:t> fall-out</a:t>
+            </a:r>
+            <a:r>
+              <a:rPr lang="en-US" sz="1600" dirty="0">
                 <a:solidFill>
                   <a:schemeClr val="dk1"/>
                 </a:solidFill>
@@ -5207,27 +5298,28 @@
                 <a:cs typeface="Calibri"/>
                 <a:sym typeface="Calibri"/>
               </a:rPr>
-              <a:t>TP / (TP + FN) </a:t>
+              <a:t>  =  FP / N  =  FP / (FP + TN)</a:t>
             </a:r>
           </a:p>
           <a:p>
             <a:pPr lvl="0"/>
             <a:r>
-              <a:rPr lang="en-US" dirty="0">
+              <a:rPr lang="en-US" sz="1600" dirty="0">
                 <a:solidFill>
                   <a:srgbClr val="00B050"/>
                 </a:solidFill>
+                <a:latin typeface="Calibri"/>
                 <a:ea typeface="Calibri"/>
                 <a:cs typeface="Calibri"/>
                 <a:sym typeface="Calibri"/>
               </a:rPr>
-              <a:t>                    ( planes classified as planes / all planes' events)</a:t>
+              <a:t>                    ( noise classified as planes / all noise events )</a:t>
             </a:r>
           </a:p>
           <a:p>
             <a:pPr lvl="0"/>
             <a:r>
-              <a:rPr lang="en-US" sz="1800" dirty="0">
+              <a:rPr lang="en-US" sz="1600" dirty="0">
                 <a:solidFill>
                   <a:schemeClr val="dk1"/>
                 </a:solidFill>
@@ -5236,39 +5328,22 @@
                 <a:cs typeface="Calibri"/>
                 <a:sym typeface="Calibri"/>
               </a:rPr>
-              <a:t>    FPR = fall-out, probability of false </a:t>
-            </a:r>
-            <a:r>
-              <a:rPr lang="en-US" dirty="0">
+              <a:t>    PRE = </a:t>
+            </a:r>
+            <a:r>
+              <a:rPr lang="en-US" sz="1600" b="1" dirty="0">
                 <a:solidFill>
-                  <a:schemeClr val="dk1"/>
-                </a:solidFill>
-                <a:ea typeface="Calibri"/>
-                <a:cs typeface="Calibri"/>
-                <a:sym typeface="Calibri"/>
-              </a:rPr>
-              <a:t>alarm = FP / (FP + TN)</a:t>
-            </a:r>
-          </a:p>
-          <a:p>
-            <a:pPr lvl="0"/>
-            <a:r>
-              <a:rPr lang="en-US" sz="1800" dirty="0">
-                <a:solidFill>
-                  <a:srgbClr val="00B050"/>
+                  <a:srgbClr val="0070C0"/>
                 </a:solidFill>
                 <a:latin typeface="Calibri"/>
                 <a:ea typeface="Calibri"/>
                 <a:cs typeface="Calibri"/>
                 <a:sym typeface="Calibri"/>
               </a:rPr>
-              <a:t>                    ( noise classified as planes / all noise events )</a:t>
-            </a:r>
-          </a:p>
-          <a:p>
-            <a:pPr lvl="0"/>
-            <a:r>
-              <a:rPr lang="en-US" sz="1800" dirty="0">
+              <a:t>Precision</a:t>
+            </a:r>
+            <a:r>
+              <a:rPr lang="en-US" sz="1600" dirty="0">
                 <a:solidFill>
                   <a:schemeClr val="dk1"/>
                 </a:solidFill>
@@ -5277,37 +5352,13 @@
                 <a:cs typeface="Calibri"/>
                 <a:sym typeface="Calibri"/>
               </a:rPr>
-              <a:t>    PRE = </a:t>
-            </a:r>
-            <a:r>
-              <a:rPr lang="en-US" sz="1800" b="1" dirty="0">
-                <a:solidFill>
-                  <a:srgbClr val="0070C0"/>
-                </a:solidFill>
-                <a:latin typeface="Calibri"/>
-                <a:ea typeface="Calibri"/>
-                <a:cs typeface="Calibri"/>
-                <a:sym typeface="Calibri"/>
-              </a:rPr>
-              <a:t>Precision</a:t>
-            </a:r>
-            <a:r>
-              <a:rPr lang="en-US" sz="1800" dirty="0">
-                <a:solidFill>
-                  <a:schemeClr val="dk1"/>
-                </a:solidFill>
-                <a:latin typeface="Calibri"/>
-                <a:ea typeface="Calibri"/>
-                <a:cs typeface="Calibri"/>
-                <a:sym typeface="Calibri"/>
-              </a:rPr>
               <a:t> = TP/(TP+FP)</a:t>
             </a:r>
           </a:p>
           <a:p>
             <a:pPr lvl="0"/>
             <a:r>
-              <a:rPr lang="en-US" dirty="0">
+              <a:rPr lang="en-US" sz="1600" dirty="0">
                 <a:solidFill>
                   <a:schemeClr val="dk1"/>
                 </a:solidFill>
@@ -5318,7 +5369,7 @@
               <a:t> </a:t>
             </a:r>
             <a:r>
-              <a:rPr lang="en-US" dirty="0">
+              <a:rPr lang="en-US" sz="1600" dirty="0">
                 <a:solidFill>
                   <a:srgbClr val="00B050"/>
                 </a:solidFill>
@@ -5327,6 +5378,55 @@
                 <a:sym typeface="Calibri"/>
               </a:rPr>
               <a:t>                   ( planes classified as planes / all events classified as planes)</a:t>
+            </a:r>
+          </a:p>
+          <a:p>
+            <a:r>
+              <a:rPr lang="en-US" sz="1600" dirty="0">
+                <a:solidFill>
+                  <a:schemeClr val="dk1"/>
+                </a:solidFill>
+                <a:ea typeface="Calibri"/>
+                <a:cs typeface="Calibri"/>
+                <a:sym typeface="Calibri"/>
+              </a:rPr>
+              <a:t>    TNR = SPC = </a:t>
+            </a:r>
+            <a:r>
+              <a:rPr lang="en-US" sz="1600" b="1" dirty="0">
+                <a:solidFill>
+                  <a:srgbClr val="0070C0"/>
+                </a:solidFill>
+                <a:ea typeface="Calibri"/>
+                <a:cs typeface="Calibri"/>
+                <a:sym typeface="Calibri"/>
+              </a:rPr>
+              <a:t>Specificity</a:t>
+            </a:r>
+            <a:r>
+              <a:rPr lang="en-US" sz="1600" dirty="0">
+                <a:solidFill>
+                  <a:schemeClr val="dk1"/>
+                </a:solidFill>
+                <a:ea typeface="Calibri"/>
+                <a:cs typeface="Calibri"/>
+                <a:sym typeface="Calibri"/>
+              </a:rPr>
+              <a:t> = TN/N  =  TN/(FP+TN)</a:t>
+            </a:r>
+          </a:p>
+          <a:p>
+            <a:pPr lvl="0"/>
+            <a:r>
+              <a:rPr lang="en-US" sz="1600" dirty="0">
+                <a:solidFill>
+                  <a:srgbClr val="00B050"/>
+                </a:solidFill>
+                <a:ea typeface="Calibri"/>
+                <a:cs typeface="Calibri"/>
+                <a:sym typeface="Calibri"/>
+              </a:rPr>
+              <a:t>                    (True Negative Rate)</a:t>
             </a:r>
           </a:p>
           <a:p>
@@ -5366,10 +5466,18 @@
               <a:buNone/>
             </a:pPr>
             <a:r>
-              <a:rPr lang="en-US" sz="3200" b="1" dirty="0"/>
+              <a:rPr lang="en-US" sz="2800" b="1" dirty="0">
+                <a:solidFill>
+                  <a:schemeClr val="accent2"/>
+                </a:solidFill>
+              </a:rPr>
               <a:t>AUC = Area Under the Curve</a:t>
             </a:r>
-            <a:endParaRPr sz="3200" b="1" dirty="0"/>
+            <a:endParaRPr sz="2800" b="1" dirty="0">
+              <a:solidFill>
+                <a:schemeClr val="accent2"/>
+              </a:solidFill>
+            </a:endParaRPr>
           </a:p>
           <a:p>
             <a:pPr marL="0" marR="0" lvl="0" indent="0" algn="l" rtl="0">
@@ -5382,7 +5490,7 @@
               <a:buNone/>
             </a:pPr>
             <a:r>
-              <a:rPr lang="en-US" sz="1800" dirty="0">
+              <a:rPr lang="en-US" sz="1600" dirty="0">
                 <a:solidFill>
                   <a:schemeClr val="dk1"/>
                 </a:solidFill>
@@ -5429,9 +5537,9 @@
               <a:buNone/>
             </a:pPr>
             <a:r>
-              <a:rPr lang="en-US" sz="3200" b="1" dirty="0">
+              <a:rPr lang="en-US" sz="2800" b="1" dirty="0">
                 <a:solidFill>
-                  <a:schemeClr val="dk1"/>
+                  <a:schemeClr val="accent2"/>
                 </a:solidFill>
                 <a:latin typeface="Calibri"/>
                 <a:cs typeface="Calibri"/>
@@ -5439,9 +5547,9 @@
               </a:rPr>
               <a:t>F1 Score</a:t>
             </a:r>
-            <a:endParaRPr lang="en-US" dirty="0">
+            <a:endParaRPr lang="en-US" sz="2800" dirty="0">
               <a:solidFill>
-                <a:schemeClr val="dk1"/>
+                <a:schemeClr val="accent2"/>
               </a:solidFill>
               <a:latin typeface="Calibri"/>
               <a:ea typeface="Calibri"/>
@@ -5460,7 +5568,7 @@
               <a:buNone/>
             </a:pPr>
             <a:r>
-              <a:rPr lang="en-US" sz="1800" dirty="0">
+              <a:rPr lang="en-US" sz="1600" dirty="0">
                 <a:solidFill>
                   <a:schemeClr val="dk1"/>
                 </a:solidFill>
@@ -5471,7 +5579,7 @@
               </a:rPr>
               <a:t>F1 score is a single number evaluation metric:</a:t>
             </a:r>
-            <a:endParaRPr dirty="0"/>
+            <a:endParaRPr sz="1600" dirty="0"/>
           </a:p>
           <a:p>
             <a:pPr marL="0" marR="0" lvl="0" indent="0" algn="l" rtl="0">
@@ -5484,7 +5592,7 @@
               <a:buNone/>
             </a:pPr>
             <a:r>
-              <a:rPr lang="en-US" sz="1800" dirty="0">
+              <a:rPr lang="en-US" sz="1600" dirty="0">
                 <a:solidFill>
                   <a:schemeClr val="dk1"/>
                 </a:solidFill>
@@ -5495,7 +5603,7 @@
               </a:rPr>
               <a:t>      F1 score = 2 * PRE * REC / (PRE + REC)</a:t>
             </a:r>
-            <a:endParaRPr sz="1800" dirty="0">
+            <a:endParaRPr sz="1600" dirty="0">
               <a:solidFill>
                 <a:schemeClr val="dk1"/>
               </a:solidFill>
@@ -5516,7 +5624,7 @@
               <a:buNone/>
             </a:pPr>
             <a:r>
-              <a:rPr lang="en-US" sz="1800" dirty="0">
+              <a:rPr lang="en-US" sz="1600" dirty="0">
                 <a:solidFill>
                   <a:schemeClr val="dk1"/>
                 </a:solidFill>
@@ -5528,7 +5636,7 @@
               <a:t>So the </a:t>
             </a:r>
             <a:r>
-              <a:rPr lang="en-US" sz="1800" b="1" dirty="0">
+              <a:rPr lang="en-US" sz="1600" b="1" dirty="0">
                 <a:solidFill>
                   <a:srgbClr val="0070C0"/>
                 </a:solidFill>
@@ -5540,7 +5648,7 @@
               <a:t>F1 score</a:t>
             </a:r>
             <a:r>
-              <a:rPr lang="en-US" sz="1800" dirty="0">
+              <a:rPr lang="en-US" sz="1600" dirty="0">
                 <a:solidFill>
                   <a:schemeClr val="dk1"/>
                 </a:solidFill>
@@ -5552,7 +5660,7 @@
               <a:t> is the harmonic average of the </a:t>
             </a:r>
             <a:r>
-              <a:rPr lang="en-US" sz="1800" b="1" dirty="0">
+              <a:rPr lang="en-US" sz="1600" b="1" dirty="0">
                 <a:solidFill>
                   <a:srgbClr val="0070C0"/>
                 </a:solidFill>
@@ -5564,7 +5672,7 @@
               <a:t>precision</a:t>
             </a:r>
             <a:r>
-              <a:rPr lang="en-US" sz="1800" dirty="0">
+              <a:rPr lang="en-US" sz="1600" dirty="0">
                 <a:solidFill>
                   <a:schemeClr val="dk1"/>
                 </a:solidFill>
@@ -5576,7 +5684,7 @@
               <a:t> and </a:t>
             </a:r>
             <a:r>
-              <a:rPr lang="en-US" sz="1800" b="1" dirty="0">
+              <a:rPr lang="en-US" sz="1600" b="1" dirty="0">
                 <a:solidFill>
                   <a:srgbClr val="0070C0"/>
                 </a:solidFill>
@@ -5588,7 +5696,7 @@
               <a:t>recall</a:t>
             </a:r>
             <a:r>
-              <a:rPr lang="en-US" sz="1800" dirty="0">
+              <a:rPr lang="en-US" sz="1600" dirty="0">
                 <a:solidFill>
                   <a:schemeClr val="dk1"/>
                 </a:solidFill>
@@ -5599,7 +5707,7 @@
               </a:rPr>
               <a:t>.</a:t>
             </a:r>
-            <a:endParaRPr sz="1800" dirty="0">
+            <a:endParaRPr sz="1600" dirty="0">
               <a:solidFill>
                 <a:schemeClr val="dk1"/>
               </a:solidFill>
@@ -6039,6 +6147,84 @@
             <a:r>
               <a:rPr lang="en-US" sz="900" b="1" dirty="0"/>
               <a:t>High Threshold</a:t>
+            </a:r>
+          </a:p>
+        </p:txBody>
+      </p:sp>
+      <p:sp>
+        <p:nvSpPr>
+          <p:cNvPr id="12" name="TextBox 11">
+            <a:extLst>
+              <a:ext uri="{FF2B5EF4-FFF2-40B4-BE49-F238E27FC236}">
+                <a16:creationId xmlns:a16="http://schemas.microsoft.com/office/drawing/2014/main" id="{C7C32A34-CA46-D74D-AA45-2D38056245CF}"/>
+              </a:ext>
+            </a:extLst>
+          </p:cNvPr>
+          <p:cNvSpPr txBox="1"/>
+          <p:nvPr/>
+        </p:nvSpPr>
+        <p:spPr>
+          <a:xfrm rot="18665804">
+            <a:off x="6655239" y="429809"/>
+            <a:ext cx="673700" cy="307777"/>
+          </a:xfrm>
+          <a:prstGeom prst="rect">
+            <a:avLst/>
+          </a:prstGeom>
+          <a:noFill/>
+        </p:spPr>
+        <p:txBody>
+          <a:bodyPr wrap="square" rtlCol="0">
+            <a:spAutoFit/>
+          </a:bodyPr>
+          <a:lstStyle/>
+          <a:p>
+            <a:r>
+              <a:rPr lang="en-US" sz="1400" dirty="0">
+                <a:solidFill>
+                  <a:srgbClr val="0070C0"/>
+                </a:solidFill>
+              </a:rPr>
+              <a:t>Recall</a:t>
+            </a:r>
+          </a:p>
+        </p:txBody>
+      </p:sp>
+      <p:sp>
+        <p:nvSpPr>
+          <p:cNvPr id="15" name="TextBox 14">
+            <a:extLst>
+              <a:ext uri="{FF2B5EF4-FFF2-40B4-BE49-F238E27FC236}">
+                <a16:creationId xmlns:a16="http://schemas.microsoft.com/office/drawing/2014/main" id="{D7D49857-F54A-7B4F-97B4-553B518E0CC0}"/>
+              </a:ext>
+            </a:extLst>
+          </p:cNvPr>
+          <p:cNvSpPr txBox="1"/>
+          <p:nvPr/>
+        </p:nvSpPr>
+        <p:spPr>
+          <a:xfrm rot="18665804">
+            <a:off x="8975833" y="2613420"/>
+            <a:ext cx="462463" cy="307777"/>
+          </a:xfrm>
+          <a:prstGeom prst="rect">
+            <a:avLst/>
+          </a:prstGeom>
+          <a:noFill/>
+        </p:spPr>
+        <p:txBody>
+          <a:bodyPr wrap="square" rtlCol="0">
+            <a:spAutoFit/>
+          </a:bodyPr>
+          <a:lstStyle/>
+          <a:p>
+            <a:r>
+              <a:rPr lang="en-US" sz="1400" dirty="0">
+                <a:solidFill>
+                  <a:srgbClr val="0070C0"/>
+                </a:solidFill>
+              </a:rPr>
+              <a:t>FPR</a:t>
             </a:r>
           </a:p>
         </p:txBody>
@@ -6088,7 +6274,13 @@
           <p:nvPr/>
         </p:nvPicPr>
         <p:blipFill>
-          <a:blip r:embed="rId2"/>
+          <a:blip r:embed="rId2" cstate="email">
+            <a:extLst>
+              <a:ext uri="{28A0092B-C50C-407E-A947-70E740481C1C}">
+                <a14:useLocalDpi xmlns:a14="http://schemas.microsoft.com/office/drawing/2010/main"/>
+              </a:ext>
+            </a:extLst>
+          </a:blip>
           <a:stretch>
             <a:fillRect/>
           </a:stretch>
@@ -9651,6 +9843,586 @@
     <p:extLst>
       <p:ext uri="{BB962C8B-B14F-4D97-AF65-F5344CB8AC3E}">
         <p14:creationId xmlns:p14="http://schemas.microsoft.com/office/powerpoint/2010/main" val="310438735"/>
+      </p:ext>
+    </p:extLst>
+  </p:cSld>
+  <p:clrMapOvr>
+    <a:masterClrMapping/>
+  </p:clrMapOvr>
+</p:sld>
+</file>
+
+<file path=ppt/slides/slide6.xml><?xml version="1.0" encoding="utf-8"?>
+<p:sld xmlns:a="http://schemas.openxmlformats.org/drawingml/2006/main" xmlns:r="http://schemas.openxmlformats.org/officeDocument/2006/relationships" xmlns:p="http://schemas.openxmlformats.org/presentationml/2006/main">
+  <p:cSld>
+    <p:spTree>
+      <p:nvGrpSpPr>
+        <p:cNvPr id="1" name=""/>
+        <p:cNvGrpSpPr/>
+        <p:nvPr/>
+      </p:nvGrpSpPr>
+      <p:grpSpPr>
+        <a:xfrm>
+          <a:off x="0" y="0"/>
+          <a:ext cx="0" cy="0"/>
+          <a:chOff x="0" y="0"/>
+          <a:chExt cx="0" cy="0"/>
+        </a:xfrm>
+      </p:grpSpPr>
+      <p:sp>
+        <p:nvSpPr>
+          <p:cNvPr id="2" name="TextBox 1">
+            <a:extLst>
+              <a:ext uri="{FF2B5EF4-FFF2-40B4-BE49-F238E27FC236}">
+                <a16:creationId xmlns:a16="http://schemas.microsoft.com/office/drawing/2014/main" id="{3870D264-F06E-B444-91D8-0D5DA897ED83}"/>
+              </a:ext>
+            </a:extLst>
+          </p:cNvPr>
+          <p:cNvSpPr txBox="1"/>
+          <p:nvPr/>
+        </p:nvSpPr>
+        <p:spPr>
+          <a:xfrm>
+            <a:off x="133815" y="122663"/>
+            <a:ext cx="11255674" cy="523220"/>
+          </a:xfrm>
+          <a:prstGeom prst="rect">
+            <a:avLst/>
+          </a:prstGeom>
+          <a:noFill/>
+        </p:spPr>
+        <p:txBody>
+          <a:bodyPr wrap="square" rtlCol="0">
+            <a:spAutoFit/>
+          </a:bodyPr>
+          <a:lstStyle/>
+          <a:p>
+            <a:r>
+              <a:rPr lang="en-US" sz="2800" b="1" dirty="0"/>
+              <a:t>Medical Test Paradox – Predictive Power of Positive or Negative Test Result</a:t>
+            </a:r>
+          </a:p>
+        </p:txBody>
+      </p:sp>
+      <p:sp>
+        <p:nvSpPr>
+          <p:cNvPr id="3" name="TextBox 2">
+            <a:extLst>
+              <a:ext uri="{FF2B5EF4-FFF2-40B4-BE49-F238E27FC236}">
+                <a16:creationId xmlns:a16="http://schemas.microsoft.com/office/drawing/2014/main" id="{8E05CF1F-B716-9C47-9B0F-5C157DE1741D}"/>
+              </a:ext>
+            </a:extLst>
+          </p:cNvPr>
+          <p:cNvSpPr txBox="1"/>
+          <p:nvPr/>
+        </p:nvSpPr>
+        <p:spPr>
+          <a:xfrm>
+            <a:off x="133816" y="645883"/>
+            <a:ext cx="4337824" cy="307777"/>
+          </a:xfrm>
+          <a:prstGeom prst="rect">
+            <a:avLst/>
+          </a:prstGeom>
+          <a:noFill/>
+        </p:spPr>
+        <p:txBody>
+          <a:bodyPr wrap="square" rtlCol="0">
+            <a:spAutoFit/>
+          </a:bodyPr>
+          <a:lstStyle/>
+          <a:p>
+            <a:r>
+              <a:rPr lang="en-US" sz="1400" dirty="0"/>
+              <a:t>from </a:t>
+            </a:r>
+            <a:r>
+              <a:rPr lang="en-US" sz="1400" dirty="0">
+                <a:hlinkClick r:id="rId2"/>
+              </a:rPr>
+              <a:t>https://www.youtube.com/watch?v=lG4VkPoG3ko</a:t>
+            </a:r>
+            <a:r>
+              <a:rPr lang="en-US" sz="1400" dirty="0"/>
+              <a:t> </a:t>
+            </a:r>
+          </a:p>
+        </p:txBody>
+      </p:sp>
+      <p:sp>
+        <p:nvSpPr>
+          <p:cNvPr id="4" name="TextBox 3">
+            <a:extLst>
+              <a:ext uri="{FF2B5EF4-FFF2-40B4-BE49-F238E27FC236}">
+                <a16:creationId xmlns:a16="http://schemas.microsoft.com/office/drawing/2014/main" id="{6A015FA5-9F2A-E743-BA81-54B9A767ADD5}"/>
+              </a:ext>
+            </a:extLst>
+          </p:cNvPr>
+          <p:cNvSpPr txBox="1"/>
+          <p:nvPr/>
+        </p:nvSpPr>
+        <p:spPr>
+          <a:xfrm>
+            <a:off x="219919" y="1099595"/>
+            <a:ext cx="8055980" cy="4555093"/>
+          </a:xfrm>
+          <a:prstGeom prst="rect">
+            <a:avLst/>
+          </a:prstGeom>
+          <a:noFill/>
+        </p:spPr>
+        <p:txBody>
+          <a:bodyPr wrap="square" rtlCol="0">
+            <a:spAutoFit/>
+          </a:bodyPr>
+          <a:lstStyle/>
+          <a:p>
+            <a:r>
+              <a:rPr lang="en-US" sz="1400" dirty="0"/>
+              <a:t>We have 1,000 people.</a:t>
+            </a:r>
+          </a:p>
+          <a:p>
+            <a:r>
+              <a:rPr lang="en-US" sz="1400" dirty="0"/>
+              <a:t>1% of them have a disease:</a:t>
+            </a:r>
+          </a:p>
+          <a:p>
+            <a:r>
+              <a:rPr lang="en-US" sz="1400" dirty="0"/>
+              <a:t>    </a:t>
+            </a:r>
+            <a:r>
+              <a:rPr lang="en-US" sz="1400" dirty="0" err="1"/>
+              <a:t>N_sick</a:t>
+            </a:r>
+            <a:r>
+              <a:rPr lang="en-US" sz="1400" dirty="0"/>
+              <a:t> = 10</a:t>
+            </a:r>
+          </a:p>
+          <a:p>
+            <a:r>
+              <a:rPr lang="en-US" sz="1400" dirty="0"/>
+              <a:t>    </a:t>
+            </a:r>
+            <a:r>
+              <a:rPr lang="en-US" sz="1400" dirty="0" err="1"/>
+              <a:t>N_healthy</a:t>
+            </a:r>
+            <a:r>
+              <a:rPr lang="en-US" sz="1400" dirty="0"/>
+              <a:t> = 990</a:t>
+            </a:r>
+          </a:p>
+          <a:p>
+            <a:endParaRPr lang="en-US" sz="1400" dirty="0"/>
+          </a:p>
+          <a:p>
+            <a:r>
+              <a:rPr lang="en-US" sz="1400" dirty="0"/>
+              <a:t>We use a test with sensitivity </a:t>
+            </a:r>
+            <a:r>
+              <a:rPr lang="en-US" sz="1400" b="1" dirty="0">
+                <a:solidFill>
+                  <a:srgbClr val="0070C0"/>
+                </a:solidFill>
+              </a:rPr>
+              <a:t>SE</a:t>
+            </a:r>
+            <a:r>
+              <a:rPr lang="en-US" sz="1400" dirty="0"/>
+              <a:t> = 90% and specificity </a:t>
+            </a:r>
+            <a:r>
+              <a:rPr lang="en-US" sz="1400" b="1" dirty="0">
+                <a:solidFill>
+                  <a:srgbClr val="0070C0"/>
+                </a:solidFill>
+              </a:rPr>
+              <a:t>SP</a:t>
+            </a:r>
+            <a:r>
+              <a:rPr lang="en-US" sz="1400" dirty="0"/>
+              <a:t> = 91%.</a:t>
+            </a:r>
+          </a:p>
+          <a:p>
+            <a:endParaRPr lang="en-US" sz="1400" dirty="0"/>
+          </a:p>
+          <a:p>
+            <a:r>
+              <a:rPr lang="en-US" sz="1400" dirty="0"/>
+              <a:t>This means that test shows results as following:</a:t>
+            </a:r>
+          </a:p>
+          <a:p>
+            <a:endParaRPr lang="en-US" sz="1400" dirty="0"/>
+          </a:p>
+          <a:p>
+            <a:r>
+              <a:rPr lang="en-US" sz="1400" b="1" dirty="0">
+                <a:solidFill>
+                  <a:srgbClr val="0070C0"/>
+                </a:solidFill>
+                <a:latin typeface="Menlo" panose="020B0609030804020204" pitchFamily="49" charset="0"/>
+                <a:ea typeface="Menlo" panose="020B0609030804020204" pitchFamily="49" charset="0"/>
+                <a:cs typeface="Menlo" panose="020B0609030804020204" pitchFamily="49" charset="0"/>
+              </a:rPr>
+              <a:t>TP = True Positive  = </a:t>
+            </a:r>
+            <a:r>
+              <a:rPr lang="en-US" sz="1400" b="1" dirty="0" err="1">
+                <a:solidFill>
+                  <a:srgbClr val="0070C0"/>
+                </a:solidFill>
+                <a:latin typeface="Menlo" panose="020B0609030804020204" pitchFamily="49" charset="0"/>
+                <a:ea typeface="Menlo" panose="020B0609030804020204" pitchFamily="49" charset="0"/>
+                <a:cs typeface="Menlo" panose="020B0609030804020204" pitchFamily="49" charset="0"/>
+              </a:rPr>
+              <a:t>N_sick</a:t>
+            </a:r>
+            <a:r>
+              <a:rPr lang="en-US" sz="1400" b="1" dirty="0">
+                <a:solidFill>
+                  <a:srgbClr val="0070C0"/>
+                </a:solidFill>
+                <a:latin typeface="Menlo" panose="020B0609030804020204" pitchFamily="49" charset="0"/>
+                <a:ea typeface="Menlo" panose="020B0609030804020204" pitchFamily="49" charset="0"/>
+                <a:cs typeface="Menlo" panose="020B0609030804020204" pitchFamily="49" charset="0"/>
+              </a:rPr>
+              <a:t>    * SE/100 =   9 out of  10</a:t>
+            </a:r>
+          </a:p>
+          <a:p>
+            <a:r>
+              <a:rPr lang="en-US" sz="1400" b="1" dirty="0">
+                <a:solidFill>
+                  <a:srgbClr val="0070C0"/>
+                </a:solidFill>
+                <a:latin typeface="Menlo" panose="020B0609030804020204" pitchFamily="49" charset="0"/>
+                <a:ea typeface="Menlo" panose="020B0609030804020204" pitchFamily="49" charset="0"/>
+                <a:cs typeface="Menlo" panose="020B0609030804020204" pitchFamily="49" charset="0"/>
+              </a:rPr>
+              <a:t>TN = True Negative  = </a:t>
+            </a:r>
+            <a:r>
+              <a:rPr lang="en-US" sz="1400" b="1" dirty="0" err="1">
+                <a:solidFill>
+                  <a:srgbClr val="0070C0"/>
+                </a:solidFill>
+                <a:latin typeface="Menlo" panose="020B0609030804020204" pitchFamily="49" charset="0"/>
+                <a:ea typeface="Menlo" panose="020B0609030804020204" pitchFamily="49" charset="0"/>
+                <a:cs typeface="Menlo" panose="020B0609030804020204" pitchFamily="49" charset="0"/>
+              </a:rPr>
+              <a:t>N_healthy</a:t>
+            </a:r>
+            <a:r>
+              <a:rPr lang="en-US" sz="1400" b="1" dirty="0">
+                <a:solidFill>
+                  <a:srgbClr val="0070C0"/>
+                </a:solidFill>
+                <a:latin typeface="Menlo" panose="020B0609030804020204" pitchFamily="49" charset="0"/>
+                <a:ea typeface="Menlo" panose="020B0609030804020204" pitchFamily="49" charset="0"/>
+                <a:cs typeface="Menlo" panose="020B0609030804020204" pitchFamily="49" charset="0"/>
+              </a:rPr>
+              <a:t> * SP/100 = 901 out of 990</a:t>
+            </a:r>
+          </a:p>
+          <a:p>
+            <a:endParaRPr lang="en-US" sz="1400" b="1" dirty="0">
+              <a:solidFill>
+                <a:srgbClr val="0070C0"/>
+              </a:solidFill>
+              <a:latin typeface="Menlo" panose="020B0609030804020204" pitchFamily="49" charset="0"/>
+              <a:ea typeface="Menlo" panose="020B0609030804020204" pitchFamily="49" charset="0"/>
+              <a:cs typeface="Menlo" panose="020B0609030804020204" pitchFamily="49" charset="0"/>
+            </a:endParaRPr>
+          </a:p>
+          <a:p>
+            <a:r>
+              <a:rPr lang="en-US" sz="1400" b="1" dirty="0">
+                <a:solidFill>
+                  <a:srgbClr val="0070C0"/>
+                </a:solidFill>
+                <a:latin typeface="Menlo" panose="020B0609030804020204" pitchFamily="49" charset="0"/>
+                <a:ea typeface="Menlo" panose="020B0609030804020204" pitchFamily="49" charset="0"/>
+                <a:cs typeface="Menlo" panose="020B0609030804020204" pitchFamily="49" charset="0"/>
+              </a:rPr>
+              <a:t>FN = False Negative =  1 out of  10</a:t>
+            </a:r>
+          </a:p>
+          <a:p>
+            <a:r>
+              <a:rPr lang="en-US" sz="1400" b="1" dirty="0">
+                <a:solidFill>
+                  <a:srgbClr val="0070C0"/>
+                </a:solidFill>
+                <a:latin typeface="Menlo" panose="020B0609030804020204" pitchFamily="49" charset="0"/>
+                <a:ea typeface="Menlo" panose="020B0609030804020204" pitchFamily="49" charset="0"/>
+                <a:cs typeface="Menlo" panose="020B0609030804020204" pitchFamily="49" charset="0"/>
+              </a:rPr>
+              <a:t>FP = False Positive = 89 out of 990</a:t>
+            </a:r>
+          </a:p>
+          <a:p>
+            <a:endParaRPr lang="en-US" sz="1400" dirty="0"/>
+          </a:p>
+          <a:p>
+            <a:r>
+              <a:rPr lang="en-US" sz="2400" b="1" dirty="0">
+                <a:solidFill>
+                  <a:srgbClr val="00B050"/>
+                </a:solidFill>
+              </a:rPr>
+              <a:t>What is the predictive power of this test?</a:t>
+            </a:r>
+          </a:p>
+          <a:p>
+            <a:endParaRPr lang="en-US" sz="1400" dirty="0"/>
+          </a:p>
+          <a:p>
+            <a:r>
+              <a:rPr lang="en-US" sz="1400" b="1" dirty="0">
+                <a:solidFill>
+                  <a:srgbClr val="00B050"/>
+                </a:solidFill>
+                <a:latin typeface="Menlo" panose="020B0609030804020204" pitchFamily="49" charset="0"/>
+                <a:ea typeface="Menlo" panose="020B0609030804020204" pitchFamily="49" charset="0"/>
+                <a:cs typeface="Menlo" panose="020B0609030804020204" pitchFamily="49" charset="0"/>
+              </a:rPr>
+              <a:t>Positive result :  TP/(TP+FP)  =    9/(9+89)   =  0.092  (1 in 11 chance)</a:t>
+            </a:r>
+          </a:p>
+          <a:p>
+            <a:endParaRPr lang="en-US" sz="1400" b="1" dirty="0">
+              <a:solidFill>
+                <a:srgbClr val="00B050"/>
+              </a:solidFill>
+              <a:latin typeface="Menlo" panose="020B0609030804020204" pitchFamily="49" charset="0"/>
+              <a:ea typeface="Menlo" panose="020B0609030804020204" pitchFamily="49" charset="0"/>
+              <a:cs typeface="Menlo" panose="020B0609030804020204" pitchFamily="49" charset="0"/>
+            </a:endParaRPr>
+          </a:p>
+          <a:p>
+            <a:r>
+              <a:rPr lang="en-US" sz="1400" b="1" dirty="0">
+                <a:solidFill>
+                  <a:srgbClr val="00B050"/>
+                </a:solidFill>
+                <a:latin typeface="Menlo" panose="020B0609030804020204" pitchFamily="49" charset="0"/>
+                <a:ea typeface="Menlo" panose="020B0609030804020204" pitchFamily="49" charset="0"/>
+                <a:cs typeface="Menlo" panose="020B0609030804020204" pitchFamily="49" charset="0"/>
+              </a:rPr>
+              <a:t>Negative result :  TN/(TN+FN)  =  901/(901+1)  =  0.999  (very good)</a:t>
+            </a:r>
+          </a:p>
+        </p:txBody>
+      </p:sp>
+      <p:graphicFrame>
+        <p:nvGraphicFramePr>
+          <p:cNvPr id="7" name="Table 7">
+            <a:extLst>
+              <a:ext uri="{FF2B5EF4-FFF2-40B4-BE49-F238E27FC236}">
+                <a16:creationId xmlns:a16="http://schemas.microsoft.com/office/drawing/2014/main" id="{CA7F8B04-1F38-2B4E-BD4A-9D68DD8A86BE}"/>
+              </a:ext>
+            </a:extLst>
+          </p:cNvPr>
+          <p:cNvGraphicFramePr>
+            <a:graphicFrameLocks noGrp="1"/>
+          </p:cNvGraphicFramePr>
+          <p:nvPr>
+            <p:extLst>
+              <p:ext uri="{D42A27DB-BD31-4B8C-83A1-F6EECF244321}">
+                <p14:modId xmlns:p14="http://schemas.microsoft.com/office/powerpoint/2010/main" val="4256968711"/>
+              </p:ext>
+            </p:extLst>
+          </p:nvPr>
+        </p:nvGraphicFramePr>
+        <p:xfrm>
+          <a:off x="8368496" y="2939971"/>
+          <a:ext cx="3229335" cy="1182027"/>
+        </p:xfrm>
+        <a:graphic>
+          <a:graphicData uri="http://schemas.openxmlformats.org/drawingml/2006/table">
+            <a:tbl>
+              <a:tblPr>
+                <a:tableStyleId>{5C22544A-7EE6-4342-B048-85BDC9FD1C3A}</a:tableStyleId>
+              </a:tblPr>
+              <a:tblGrid>
+                <a:gridCol w="1076445">
+                  <a:extLst>
+                    <a:ext uri="{9D8B030D-6E8A-4147-A177-3AD203B41FA5}">
+                      <a16:colId xmlns:a16="http://schemas.microsoft.com/office/drawing/2014/main" val="2903718036"/>
+                    </a:ext>
+                  </a:extLst>
+                </a:gridCol>
+                <a:gridCol w="1076445">
+                  <a:extLst>
+                    <a:ext uri="{9D8B030D-6E8A-4147-A177-3AD203B41FA5}">
+                      <a16:colId xmlns:a16="http://schemas.microsoft.com/office/drawing/2014/main" val="663645295"/>
+                    </a:ext>
+                  </a:extLst>
+                </a:gridCol>
+                <a:gridCol w="1076445">
+                  <a:extLst>
+                    <a:ext uri="{9D8B030D-6E8A-4147-A177-3AD203B41FA5}">
+                      <a16:colId xmlns:a16="http://schemas.microsoft.com/office/drawing/2014/main" val="3368044933"/>
+                    </a:ext>
+                  </a:extLst>
+                </a:gridCol>
+              </a:tblGrid>
+              <a:tr h="394009">
+                <a:tc>
+                  <a:txBody>
+                    <a:bodyPr/>
+                    <a:lstStyle/>
+                    <a:p>
+                      <a:endParaRPr lang="en-US"/>
+                    </a:p>
+                  </a:txBody>
+                  <a:tcPr/>
+                </a:tc>
+                <a:tc>
+                  <a:txBody>
+                    <a:bodyPr/>
+                    <a:lstStyle/>
+                    <a:p>
+                      <a:pPr algn="ctr"/>
+                      <a:r>
+                        <a:rPr lang="en-US" dirty="0"/>
+                        <a:t>Disease</a:t>
+                      </a:r>
+                    </a:p>
+                  </a:txBody>
+                  <a:tcPr/>
+                </a:tc>
+                <a:tc>
+                  <a:txBody>
+                    <a:bodyPr/>
+                    <a:lstStyle/>
+                    <a:p>
+                      <a:pPr algn="ctr"/>
+                      <a:r>
+                        <a:rPr lang="en-US" dirty="0"/>
+                        <a:t>Healthy</a:t>
+                      </a:r>
+                    </a:p>
+                  </a:txBody>
+                  <a:tcPr/>
+                </a:tc>
+                <a:extLst>
+                  <a:ext uri="{0D108BD9-81ED-4DB2-BD59-A6C34878D82A}">
+                    <a16:rowId xmlns:a16="http://schemas.microsoft.com/office/drawing/2014/main" val="3644456898"/>
+                  </a:ext>
+                </a:extLst>
+              </a:tr>
+              <a:tr h="394009">
+                <a:tc>
+                  <a:txBody>
+                    <a:bodyPr/>
+                    <a:lstStyle/>
+                    <a:p>
+                      <a:r>
+                        <a:rPr lang="en-US" dirty="0"/>
+                        <a:t>Positive</a:t>
+                      </a:r>
+                    </a:p>
+                  </a:txBody>
+                  <a:tcPr/>
+                </a:tc>
+                <a:tc>
+                  <a:txBody>
+                    <a:bodyPr/>
+                    <a:lstStyle/>
+                    <a:p>
+                      <a:pPr algn="ctr"/>
+                      <a:r>
+                        <a:rPr lang="en-US" dirty="0"/>
+                        <a:t>9</a:t>
+                      </a:r>
+                    </a:p>
+                  </a:txBody>
+                  <a:tcPr/>
+                </a:tc>
+                <a:tc>
+                  <a:txBody>
+                    <a:bodyPr/>
+                    <a:lstStyle/>
+                    <a:p>
+                      <a:pPr algn="ctr"/>
+                      <a:r>
+                        <a:rPr lang="en-US" dirty="0"/>
+                        <a:t>89</a:t>
+                      </a:r>
+                    </a:p>
+                  </a:txBody>
+                  <a:tcPr/>
+                </a:tc>
+                <a:extLst>
+                  <a:ext uri="{0D108BD9-81ED-4DB2-BD59-A6C34878D82A}">
+                    <a16:rowId xmlns:a16="http://schemas.microsoft.com/office/drawing/2014/main" val="4270934848"/>
+                  </a:ext>
+                </a:extLst>
+              </a:tr>
+              <a:tr h="394009">
+                <a:tc>
+                  <a:txBody>
+                    <a:bodyPr/>
+                    <a:lstStyle/>
+                    <a:p>
+                      <a:r>
+                        <a:rPr lang="en-US" dirty="0"/>
+                        <a:t>Negative</a:t>
+                      </a:r>
+                    </a:p>
+                  </a:txBody>
+                  <a:tcPr/>
+                </a:tc>
+                <a:tc>
+                  <a:txBody>
+                    <a:bodyPr/>
+                    <a:lstStyle/>
+                    <a:p>
+                      <a:pPr algn="ctr"/>
+                      <a:r>
+                        <a:rPr lang="en-US" dirty="0"/>
+                        <a:t>1</a:t>
+                      </a:r>
+                    </a:p>
+                  </a:txBody>
+                  <a:tcPr/>
+                </a:tc>
+                <a:tc>
+                  <a:txBody>
+                    <a:bodyPr/>
+                    <a:lstStyle/>
+                    <a:p>
+                      <a:pPr algn="ctr"/>
+                      <a:r>
+                        <a:rPr lang="en-US" dirty="0"/>
+                        <a:t>901</a:t>
+                      </a:r>
+                    </a:p>
+                  </a:txBody>
+                  <a:tcPr/>
+                </a:tc>
+                <a:extLst>
+                  <a:ext uri="{0D108BD9-81ED-4DB2-BD59-A6C34878D82A}">
+                    <a16:rowId xmlns:a16="http://schemas.microsoft.com/office/drawing/2014/main" val="2909777930"/>
+                  </a:ext>
+                </a:extLst>
+              </a:tr>
+            </a:tbl>
+          </a:graphicData>
+        </a:graphic>
+      </p:graphicFrame>
+    </p:spTree>
+    <p:extLst>
+      <p:ext uri="{BB962C8B-B14F-4D97-AF65-F5344CB8AC3E}">
+        <p14:creationId xmlns:p14="http://schemas.microsoft.com/office/powerpoint/2010/main" val="2196185501"/>
       </p:ext>
     </p:extLst>
   </p:cSld>

</xml_diff>

<commit_message>
Added pictures of plane and radar
</commit_message>
<xml_diff>
--- a/Precision_Recall_ROC_Confusion.pptx
+++ b/Precision_Recall_ROC_Confusion.pptx
@@ -974,7 +974,7 @@
           <a:p>
             <a:fld id="{AC91B679-F1BC-D040-817F-A2F595AB9D9A}" type="datetimeFigureOut">
               <a:rPr lang="en-US" smtClean="0"/>
-              <a:t>2/6/21</a:t>
+              <a:t>2/11/21</a:t>
             </a:fld>
             <a:endParaRPr lang="en-US"/>
           </a:p>
@@ -1824,7 +1824,7 @@
           <a:p>
             <a:fld id="{F1DC6890-0266-1140-AA82-3B7AF23274A1}" type="datetimeFigureOut">
               <a:rPr lang="en-US" smtClean="0"/>
-              <a:t>2/6/21</a:t>
+              <a:t>2/11/21</a:t>
             </a:fld>
             <a:endParaRPr lang="en-US"/>
           </a:p>
@@ -2022,7 +2022,7 @@
           <a:p>
             <a:fld id="{F1DC6890-0266-1140-AA82-3B7AF23274A1}" type="datetimeFigureOut">
               <a:rPr lang="en-US" smtClean="0"/>
-              <a:t>2/6/21</a:t>
+              <a:t>2/11/21</a:t>
             </a:fld>
             <a:endParaRPr lang="en-US"/>
           </a:p>
@@ -2230,7 +2230,7 @@
           <a:p>
             <a:fld id="{F1DC6890-0266-1140-AA82-3B7AF23274A1}" type="datetimeFigureOut">
               <a:rPr lang="en-US" smtClean="0"/>
-              <a:t>2/6/21</a:t>
+              <a:t>2/11/21</a:t>
             </a:fld>
             <a:endParaRPr lang="en-US"/>
           </a:p>
@@ -2428,7 +2428,7 @@
           <a:p>
             <a:fld id="{F1DC6890-0266-1140-AA82-3B7AF23274A1}" type="datetimeFigureOut">
               <a:rPr lang="en-US" smtClean="0"/>
-              <a:t>2/6/21</a:t>
+              <a:t>2/11/21</a:t>
             </a:fld>
             <a:endParaRPr lang="en-US"/>
           </a:p>
@@ -2703,7 +2703,7 @@
           <a:p>
             <a:fld id="{F1DC6890-0266-1140-AA82-3B7AF23274A1}" type="datetimeFigureOut">
               <a:rPr lang="en-US" smtClean="0"/>
-              <a:t>2/6/21</a:t>
+              <a:t>2/11/21</a:t>
             </a:fld>
             <a:endParaRPr lang="en-US"/>
           </a:p>
@@ -2968,7 +2968,7 @@
           <a:p>
             <a:fld id="{F1DC6890-0266-1140-AA82-3B7AF23274A1}" type="datetimeFigureOut">
               <a:rPr lang="en-US" smtClean="0"/>
-              <a:t>2/6/21</a:t>
+              <a:t>2/11/21</a:t>
             </a:fld>
             <a:endParaRPr lang="en-US"/>
           </a:p>
@@ -3380,7 +3380,7 @@
           <a:p>
             <a:fld id="{F1DC6890-0266-1140-AA82-3B7AF23274A1}" type="datetimeFigureOut">
               <a:rPr lang="en-US" smtClean="0"/>
-              <a:t>2/6/21</a:t>
+              <a:t>2/11/21</a:t>
             </a:fld>
             <a:endParaRPr lang="en-US"/>
           </a:p>
@@ -3521,7 +3521,7 @@
           <a:p>
             <a:fld id="{F1DC6890-0266-1140-AA82-3B7AF23274A1}" type="datetimeFigureOut">
               <a:rPr lang="en-US" smtClean="0"/>
-              <a:t>2/6/21</a:t>
+              <a:t>2/11/21</a:t>
             </a:fld>
             <a:endParaRPr lang="en-US"/>
           </a:p>
@@ -3634,7 +3634,7 @@
           <a:p>
             <a:fld id="{F1DC6890-0266-1140-AA82-3B7AF23274A1}" type="datetimeFigureOut">
               <a:rPr lang="en-US" smtClean="0"/>
-              <a:t>2/6/21</a:t>
+              <a:t>2/11/21</a:t>
             </a:fld>
             <a:endParaRPr lang="en-US"/>
           </a:p>
@@ -3945,7 +3945,7 @@
           <a:p>
             <a:fld id="{F1DC6890-0266-1140-AA82-3B7AF23274A1}" type="datetimeFigureOut">
               <a:rPr lang="en-US" smtClean="0"/>
-              <a:t>2/6/21</a:t>
+              <a:t>2/11/21</a:t>
             </a:fld>
             <a:endParaRPr lang="en-US"/>
           </a:p>
@@ -4233,7 +4233,7 @@
           <a:p>
             <a:fld id="{F1DC6890-0266-1140-AA82-3B7AF23274A1}" type="datetimeFigureOut">
               <a:rPr lang="en-US" smtClean="0"/>
-              <a:t>2/6/21</a:t>
+              <a:t>2/11/21</a:t>
             </a:fld>
             <a:endParaRPr lang="en-US"/>
           </a:p>
@@ -4474,7 +4474,7 @@
           <a:p>
             <a:fld id="{F1DC6890-0266-1140-AA82-3B7AF23274A1}" type="datetimeFigureOut">
               <a:rPr lang="en-US" smtClean="0"/>
-              <a:t>2/6/21</a:t>
+              <a:t>2/11/21</a:t>
             </a:fld>
             <a:endParaRPr lang="en-US"/>
           </a:p>
@@ -5005,8 +5005,8 @@
         </p:nvSpPr>
         <p:spPr>
           <a:xfrm>
-            <a:off x="64170" y="0"/>
-            <a:ext cx="7308080" cy="6763871"/>
+            <a:off x="71089" y="33930"/>
+            <a:ext cx="6244392" cy="5989489"/>
           </a:xfrm>
           <a:prstGeom prst="rect">
             <a:avLst/>
@@ -5204,6 +5204,17 @@
               <a:t>                            </a:t>
             </a:r>
             <a:r>
+              <a:rPr lang="en-US" sz="1600" b="1" dirty="0">
+                <a:solidFill>
+                  <a:srgbClr val="FF0000"/>
+                </a:solidFill>
+                <a:ea typeface="Calibri"/>
+                <a:cs typeface="Calibri"/>
+                <a:sym typeface="Calibri"/>
+              </a:rPr>
+              <a:t>at various threshold settings</a:t>
+            </a:r>
+            <a:r>
               <a:rPr lang="en-US" sz="1600" dirty="0">
                 <a:solidFill>
                   <a:schemeClr val="dk1"/>
@@ -5212,7 +5223,7 @@
                 <a:cs typeface="Calibri"/>
                 <a:sym typeface="Calibri"/>
               </a:rPr>
-              <a:t>at various threshold settings.</a:t>
+              <a:t>.</a:t>
             </a:r>
           </a:p>
           <a:p>
@@ -5607,7 +5618,7 @@
                 <a:cs typeface="Calibri"/>
                 <a:sym typeface="Calibri"/>
               </a:rPr>
-              <a:t>Simply the area under the ROC curve (from 0 to 1)</a:t>
+              <a:t>Simply the area under the ROC curve (1 = very good, 0.5 = bad)</a:t>
             </a:r>
           </a:p>
           <a:p>
@@ -5635,15 +5646,7 @@
             <a:endParaRPr dirty="0"/>
           </a:p>
           <a:p>
-            <a:pPr marL="0" marR="0" lvl="0" indent="0" algn="l" rtl="0">
-              <a:spcBef>
-                <a:spcPts val="0"/>
-              </a:spcBef>
-              <a:spcAft>
-                <a:spcPts val="0"/>
-              </a:spcAft>
-              <a:buNone/>
-            </a:pPr>
+            <a:pPr lvl="0"/>
             <a:r>
               <a:rPr lang="en-US" sz="2800" b="1" dirty="0">
                 <a:solidFill>
@@ -5655,26 +5658,6 @@
               </a:rPr>
               <a:t>F1 Score</a:t>
             </a:r>
-            <a:endParaRPr lang="en-US" sz="2800" dirty="0">
-              <a:solidFill>
-                <a:schemeClr val="accent2"/>
-              </a:solidFill>
-              <a:latin typeface="Calibri"/>
-              <a:ea typeface="Calibri"/>
-              <a:cs typeface="Calibri"/>
-              <a:sym typeface="Calibri"/>
-            </a:endParaRPr>
-          </a:p>
-          <a:p>
-            <a:pPr marL="0" marR="0" lvl="0" indent="0" algn="l" rtl="0">
-              <a:spcBef>
-                <a:spcPts val="0"/>
-              </a:spcBef>
-              <a:spcAft>
-                <a:spcPts val="0"/>
-              </a:spcAft>
-              <a:buNone/>
-            </a:pPr>
             <a:r>
               <a:rPr lang="en-US" sz="1600" dirty="0">
                 <a:solidFill>
@@ -5685,145 +5668,89 @@
                 <a:cs typeface="Calibri"/>
                 <a:sym typeface="Calibri"/>
               </a:rPr>
-              <a:t>F1 score is a single number evaluation metric:</a:t>
-            </a:r>
-            <a:endParaRPr sz="1600" dirty="0"/>
-          </a:p>
-          <a:p>
-            <a:pPr marL="0" marR="0" lvl="0" indent="0" algn="l" rtl="0">
-              <a:spcBef>
-                <a:spcPts val="0"/>
-              </a:spcBef>
-              <a:spcAft>
-                <a:spcPts val="0"/>
-              </a:spcAft>
-              <a:buNone/>
-            </a:pPr>
+              <a:t> - a single number evaluation metric</a:t>
+            </a:r>
             <a:r>
               <a:rPr lang="en-US" sz="1600" dirty="0">
                 <a:solidFill>
                   <a:schemeClr val="dk1"/>
                 </a:solidFill>
-                <a:latin typeface="Calibri"/>
                 <a:ea typeface="Calibri"/>
                 <a:cs typeface="Calibri"/>
                 <a:sym typeface="Calibri"/>
               </a:rPr>
-              <a:t>      F1 score = 2 * PRE * REC / (PRE + REC)</a:t>
-            </a:r>
-            <a:endParaRPr sz="1600" dirty="0">
-              <a:solidFill>
-                <a:schemeClr val="dk1"/>
-              </a:solidFill>
-              <a:latin typeface="Calibri"/>
-              <a:ea typeface="Calibri"/>
-              <a:cs typeface="Calibri"/>
-              <a:sym typeface="Calibri"/>
-            </a:endParaRPr>
-          </a:p>
-          <a:p>
-            <a:pPr marL="0" marR="0" lvl="0" indent="0" algn="l" rtl="0">
-              <a:spcBef>
-                <a:spcPts val="0"/>
-              </a:spcBef>
-              <a:spcAft>
-                <a:spcPts val="0"/>
-              </a:spcAft>
-              <a:buNone/>
-            </a:pPr>
+              <a:t>, harmonic average </a:t>
+            </a:r>
+          </a:p>
+          <a:p>
+            <a:pPr lvl="0"/>
             <a:r>
               <a:rPr lang="en-US" sz="1600" dirty="0">
                 <a:solidFill>
                   <a:schemeClr val="dk1"/>
                 </a:solidFill>
-                <a:latin typeface="Calibri"/>
                 <a:ea typeface="Calibri"/>
                 <a:cs typeface="Calibri"/>
                 <a:sym typeface="Calibri"/>
               </a:rPr>
-              <a:t>So the </a:t>
+              <a:t>of the </a:t>
             </a:r>
             <a:r>
               <a:rPr lang="en-US" sz="1600" b="1" dirty="0">
                 <a:solidFill>
                   <a:srgbClr val="0070C0"/>
                 </a:solidFill>
-                <a:latin typeface="Calibri"/>
                 <a:ea typeface="Calibri"/>
                 <a:cs typeface="Calibri"/>
                 <a:sym typeface="Calibri"/>
               </a:rPr>
-              <a:t>F1 score</a:t>
+              <a:t>precision</a:t>
             </a:r>
             <a:r>
               <a:rPr lang="en-US" sz="1600" dirty="0">
                 <a:solidFill>
                   <a:schemeClr val="dk1"/>
                 </a:solidFill>
-                <a:latin typeface="Calibri"/>
                 <a:ea typeface="Calibri"/>
                 <a:cs typeface="Calibri"/>
                 <a:sym typeface="Calibri"/>
               </a:rPr>
-              <a:t> is the harmonic average of the </a:t>
+              <a:t> and </a:t>
             </a:r>
             <a:r>
               <a:rPr lang="en-US" sz="1600" b="1" dirty="0">
                 <a:solidFill>
                   <a:srgbClr val="0070C0"/>
                 </a:solidFill>
-                <a:latin typeface="Calibri"/>
                 <a:ea typeface="Calibri"/>
                 <a:cs typeface="Calibri"/>
                 <a:sym typeface="Calibri"/>
               </a:rPr>
-              <a:t>precision</a:t>
+              <a:t>recall</a:t>
+            </a:r>
+            <a:r>
+              <a:rPr lang="en-US" sz="1600" b="1" dirty="0">
+                <a:solidFill>
+                  <a:schemeClr val="dk1"/>
+                </a:solidFill>
+                <a:ea typeface="Calibri"/>
+                <a:cs typeface="Calibri"/>
+                <a:sym typeface="Calibri"/>
+              </a:rPr>
+              <a:t> </a:t>
             </a:r>
             <a:r>
               <a:rPr lang="en-US" sz="1600" dirty="0">
                 <a:solidFill>
                   <a:schemeClr val="dk1"/>
                 </a:solidFill>
-                <a:latin typeface="Calibri"/>
                 <a:ea typeface="Calibri"/>
                 <a:cs typeface="Calibri"/>
                 <a:sym typeface="Calibri"/>
               </a:rPr>
-              <a:t> and </a:t>
-            </a:r>
-            <a:r>
-              <a:rPr lang="en-US" sz="1600" b="1" dirty="0">
-                <a:solidFill>
-                  <a:srgbClr val="0070C0"/>
-                </a:solidFill>
-                <a:latin typeface="Calibri"/>
-                <a:ea typeface="Calibri"/>
-                <a:cs typeface="Calibri"/>
-                <a:sym typeface="Calibri"/>
-              </a:rPr>
-              <a:t>recall</a:t>
-            </a:r>
-            <a:r>
-              <a:rPr lang="en-US" sz="1600" dirty="0">
-                <a:solidFill>
-                  <a:schemeClr val="dk1"/>
-                </a:solidFill>
-                <a:latin typeface="Calibri"/>
-                <a:ea typeface="Calibri"/>
-                <a:cs typeface="Calibri"/>
-                <a:sym typeface="Calibri"/>
-              </a:rPr>
-              <a:t>.</a:t>
-            </a:r>
-            <a:endParaRPr sz="1600" dirty="0">
-              <a:solidFill>
-                <a:schemeClr val="dk1"/>
-              </a:solidFill>
-              <a:latin typeface="Calibri"/>
-              <a:ea typeface="Calibri"/>
-              <a:cs typeface="Calibri"/>
-              <a:sym typeface="Calibri"/>
-            </a:endParaRPr>
+              <a:t>:</a:t>
+            </a:r>
+            <a:endParaRPr sz="1600" dirty="0"/>
           </a:p>
         </p:txBody>
       </p:sp>
@@ -5855,7 +5782,7 @@
         </p:blipFill>
         <p:spPr>
           <a:xfrm>
-            <a:off x="9158637" y="3799620"/>
+            <a:off x="9138885" y="966111"/>
             <a:ext cx="2979905" cy="2850776"/>
           </a:xfrm>
           <a:prstGeom prst="rect">
@@ -5863,48 +5790,12 @@
           </a:prstGeom>
         </p:spPr>
       </p:pic>
-      <p:pic>
-        <p:nvPicPr>
-          <p:cNvPr id="3" name="Picture 2">
-            <a:extLst>
-              <a:ext uri="{FF2B5EF4-FFF2-40B4-BE49-F238E27FC236}">
-                <a16:creationId xmlns:a16="http://schemas.microsoft.com/office/drawing/2014/main" id="{BB6C81F0-62C3-8E45-95A5-23522F707AD7}"/>
-              </a:ext>
-            </a:extLst>
-          </p:cNvPr>
-          <p:cNvPicPr>
-            <a:picLocks noChangeAspect="1"/>
-          </p:cNvPicPr>
-          <p:nvPr/>
-        </p:nvPicPr>
-        <p:blipFill>
-          <a:blip r:embed="rId4" cstate="email">
-            <a:extLst>
-              <a:ext uri="{28A0092B-C50C-407E-A947-70E740481C1C}">
-                <a14:useLocalDpi xmlns:a14="http://schemas.microsoft.com/office/drawing/2010/main"/>
-              </a:ext>
-            </a:extLst>
-          </a:blip>
-          <a:stretch>
-            <a:fillRect/>
-          </a:stretch>
-        </p:blipFill>
-        <p:spPr>
-          <a:xfrm>
-            <a:off x="6864524" y="242888"/>
-            <a:ext cx="5327475" cy="2689412"/>
-          </a:xfrm>
-          <a:prstGeom prst="rect">
-            <a:avLst/>
-          </a:prstGeom>
-        </p:spPr>
-      </p:pic>
-      <p:sp>
-        <p:nvSpPr>
-          <p:cNvPr id="4" name="TextBox 3">
-            <a:extLst>
-              <a:ext uri="{FF2B5EF4-FFF2-40B4-BE49-F238E27FC236}">
-                <a16:creationId xmlns:a16="http://schemas.microsoft.com/office/drawing/2014/main" id="{8771AF10-28D8-9F40-AE11-3D955B9498E7}"/>
+      <p:sp>
+        <p:nvSpPr>
+          <p:cNvPr id="5" name="TextBox 4">
+            <a:extLst>
+              <a:ext uri="{FF2B5EF4-FFF2-40B4-BE49-F238E27FC236}">
+                <a16:creationId xmlns:a16="http://schemas.microsoft.com/office/drawing/2014/main" id="{A5820A35-4F3A-ED4B-8ED0-679A3476A85F}"/>
               </a:ext>
             </a:extLst>
           </p:cNvPr>
@@ -5913,89 +5804,7 @@
         </p:nvSpPr>
         <p:spPr>
           <a:xfrm>
-            <a:off x="7879976" y="1089212"/>
-            <a:ext cx="1089212" cy="646331"/>
-          </a:xfrm>
-          <a:prstGeom prst="rect">
-            <a:avLst/>
-          </a:prstGeom>
-          <a:noFill/>
-        </p:spPr>
-        <p:txBody>
-          <a:bodyPr wrap="square" rtlCol="0">
-            <a:spAutoFit/>
-          </a:bodyPr>
-          <a:lstStyle/>
-          <a:p>
-            <a:r>
-              <a:rPr lang="en-US" dirty="0"/>
-              <a:t>ROC</a:t>
-            </a:r>
-          </a:p>
-          <a:p>
-            <a:r>
-              <a:rPr lang="en-US" dirty="0"/>
-              <a:t>Curve</a:t>
-            </a:r>
-          </a:p>
-        </p:txBody>
-      </p:sp>
-      <p:sp>
-        <p:nvSpPr>
-          <p:cNvPr id="7" name="TextBox 6">
-            <a:extLst>
-              <a:ext uri="{FF2B5EF4-FFF2-40B4-BE49-F238E27FC236}">
-                <a16:creationId xmlns:a16="http://schemas.microsoft.com/office/drawing/2014/main" id="{6A274A43-2460-0F4C-AA71-4A5D0492FF28}"/>
-              </a:ext>
-            </a:extLst>
-          </p:cNvPr>
-          <p:cNvSpPr txBox="1"/>
-          <p:nvPr/>
-        </p:nvSpPr>
-        <p:spPr>
-          <a:xfrm>
-            <a:off x="10170458" y="1089212"/>
-            <a:ext cx="1391616" cy="923330"/>
-          </a:xfrm>
-          <a:prstGeom prst="rect">
-            <a:avLst/>
-          </a:prstGeom>
-          <a:noFill/>
-        </p:spPr>
-        <p:txBody>
-          <a:bodyPr wrap="square" rtlCol="0">
-            <a:spAutoFit/>
-          </a:bodyPr>
-          <a:lstStyle/>
-          <a:p>
-            <a:r>
-              <a:rPr lang="en-US" dirty="0"/>
-              <a:t>Precision-Recall </a:t>
-            </a:r>
-          </a:p>
-          <a:p>
-            <a:r>
-              <a:rPr lang="en-US" dirty="0"/>
-              <a:t>Curve</a:t>
-            </a:r>
-          </a:p>
-        </p:txBody>
-      </p:sp>
-      <p:sp>
-        <p:nvSpPr>
-          <p:cNvPr id="5" name="TextBox 4">
-            <a:extLst>
-              <a:ext uri="{FF2B5EF4-FFF2-40B4-BE49-F238E27FC236}">
-                <a16:creationId xmlns:a16="http://schemas.microsoft.com/office/drawing/2014/main" id="{A5820A35-4F3A-ED4B-8ED0-679A3476A85F}"/>
-              </a:ext>
-            </a:extLst>
-          </p:cNvPr>
-          <p:cNvSpPr txBox="1"/>
-          <p:nvPr/>
-        </p:nvSpPr>
-        <p:spPr>
-          <a:xfrm>
-            <a:off x="7142433" y="5392399"/>
+            <a:off x="7122681" y="2558890"/>
             <a:ext cx="1858617" cy="276999"/>
           </a:xfrm>
           <a:prstGeom prst="rect">
@@ -6035,7 +5844,7 @@
         </p:nvSpPr>
         <p:spPr>
           <a:xfrm>
-            <a:off x="7142432" y="6046980"/>
+            <a:off x="7122680" y="3213471"/>
             <a:ext cx="1858617" cy="276999"/>
           </a:xfrm>
           <a:prstGeom prst="rect">
@@ -6075,7 +5884,7 @@
         </p:nvSpPr>
         <p:spPr>
           <a:xfrm rot="993956">
-            <a:off x="8993856" y="5517216"/>
+            <a:off x="8974104" y="2683707"/>
             <a:ext cx="426419" cy="162149"/>
           </a:xfrm>
           <a:prstGeom prst="rightArrow">
@@ -6121,7 +5930,7 @@
         </p:nvSpPr>
         <p:spPr>
           <a:xfrm rot="20039750">
-            <a:off x="9013870" y="6006532"/>
+            <a:off x="8994118" y="3173023"/>
             <a:ext cx="423508" cy="169505"/>
           </a:xfrm>
           <a:prstGeom prst="rightArrow">
@@ -6162,13 +5971,15 @@
               </a:ext>
             </a:extLst>
           </p:cNvPr>
-          <p:cNvCxnSpPr/>
+          <p:cNvCxnSpPr>
+            <a:cxnSpLocks/>
+          </p:cNvCxnSpPr>
           <p:nvPr/>
         </p:nvCxnSpPr>
         <p:spPr>
           <a:xfrm>
-            <a:off x="7036902" y="4442791"/>
-            <a:ext cx="0" cy="2331019"/>
+            <a:off x="6388500" y="46353"/>
+            <a:ext cx="0" cy="6751448"/>
           </a:xfrm>
           <a:prstGeom prst="line">
             <a:avLst/>
@@ -6189,12 +6000,48 @@
           </a:fontRef>
         </p:style>
       </p:cxnSp>
-      <p:sp>
-        <p:nvSpPr>
-          <p:cNvPr id="9" name="TextBox 8">
-            <a:extLst>
-              <a:ext uri="{FF2B5EF4-FFF2-40B4-BE49-F238E27FC236}">
-                <a16:creationId xmlns:a16="http://schemas.microsoft.com/office/drawing/2014/main" id="{F7824489-5BB9-F74D-8592-EA7D0BAD26C8}"/>
+      <p:pic>
+        <p:nvPicPr>
+          <p:cNvPr id="3" name="Picture 2">
+            <a:extLst>
+              <a:ext uri="{FF2B5EF4-FFF2-40B4-BE49-F238E27FC236}">
+                <a16:creationId xmlns:a16="http://schemas.microsoft.com/office/drawing/2014/main" id="{BB6C81F0-62C3-8E45-95A5-23522F707AD7}"/>
+              </a:ext>
+            </a:extLst>
+          </p:cNvPr>
+          <p:cNvPicPr>
+            <a:picLocks noChangeAspect="1"/>
+          </p:cNvPicPr>
+          <p:nvPr/>
+        </p:nvPicPr>
+        <p:blipFill>
+          <a:blip r:embed="rId4" cstate="email">
+            <a:extLst>
+              <a:ext uri="{28A0092B-C50C-407E-A947-70E740481C1C}">
+                <a14:useLocalDpi xmlns:a14="http://schemas.microsoft.com/office/drawing/2010/main"/>
+              </a:ext>
+            </a:extLst>
+          </a:blip>
+          <a:stretch>
+            <a:fillRect/>
+          </a:stretch>
+        </p:blipFill>
+        <p:spPr>
+          <a:xfrm>
+            <a:off x="6802745" y="3999861"/>
+            <a:ext cx="5327475" cy="2689412"/>
+          </a:xfrm>
+          <a:prstGeom prst="rect">
+            <a:avLst/>
+          </a:prstGeom>
+        </p:spPr>
+      </p:pic>
+      <p:sp>
+        <p:nvSpPr>
+          <p:cNvPr id="4" name="TextBox 3">
+            <a:extLst>
+              <a:ext uri="{FF2B5EF4-FFF2-40B4-BE49-F238E27FC236}">
+                <a16:creationId xmlns:a16="http://schemas.microsoft.com/office/drawing/2014/main" id="{8771AF10-28D8-9F40-AE11-3D955B9498E7}"/>
               </a:ext>
             </a:extLst>
           </p:cNvPr>
@@ -6203,8 +6050,8 @@
         </p:nvSpPr>
         <p:spPr>
           <a:xfrm>
-            <a:off x="8613861" y="468282"/>
-            <a:ext cx="914400" cy="230832"/>
+            <a:off x="7818197" y="4846185"/>
+            <a:ext cx="1089212" cy="646331"/>
           </a:xfrm>
           <a:prstGeom prst="rect">
             <a:avLst/>
@@ -6218,18 +6065,24 @@
           <a:lstStyle/>
           <a:p>
             <a:r>
-              <a:rPr lang="en-US" sz="900" b="1" dirty="0"/>
-              <a:t>Low Threshold</a:t>
-            </a:r>
-          </a:p>
-        </p:txBody>
-      </p:sp>
-      <p:sp>
-        <p:nvSpPr>
-          <p:cNvPr id="14" name="TextBox 13">
-            <a:extLst>
-              <a:ext uri="{FF2B5EF4-FFF2-40B4-BE49-F238E27FC236}">
-                <a16:creationId xmlns:a16="http://schemas.microsoft.com/office/drawing/2014/main" id="{13DD589D-266C-6547-AFFF-F661F1CA7BE7}"/>
+              <a:rPr lang="en-US" dirty="0"/>
+              <a:t>ROC</a:t>
+            </a:r>
+          </a:p>
+          <a:p>
+            <a:r>
+              <a:rPr lang="en-US" dirty="0"/>
+              <a:t>Curve</a:t>
+            </a:r>
+          </a:p>
+        </p:txBody>
+      </p:sp>
+      <p:sp>
+        <p:nvSpPr>
+          <p:cNvPr id="7" name="TextBox 6">
+            <a:extLst>
+              <a:ext uri="{FF2B5EF4-FFF2-40B4-BE49-F238E27FC236}">
+                <a16:creationId xmlns:a16="http://schemas.microsoft.com/office/drawing/2014/main" id="{6A274A43-2460-0F4C-AA71-4A5D0492FF28}"/>
               </a:ext>
             </a:extLst>
           </p:cNvPr>
@@ -6238,8 +6091,8 @@
         </p:nvSpPr>
         <p:spPr>
           <a:xfrm>
-            <a:off x="7303850" y="2266446"/>
-            <a:ext cx="914400" cy="230832"/>
+            <a:off x="10108679" y="4846185"/>
+            <a:ext cx="1391616" cy="923330"/>
           </a:xfrm>
           <a:prstGeom prst="rect">
             <a:avLst/>
@@ -6253,18 +6106,24 @@
           <a:lstStyle/>
           <a:p>
             <a:r>
-              <a:rPr lang="en-US" sz="900" b="1" dirty="0"/>
-              <a:t>High Threshold</a:t>
-            </a:r>
-          </a:p>
-        </p:txBody>
-      </p:sp>
-      <p:sp>
-        <p:nvSpPr>
-          <p:cNvPr id="12" name="TextBox 11">
-            <a:extLst>
-              <a:ext uri="{FF2B5EF4-FFF2-40B4-BE49-F238E27FC236}">
-                <a16:creationId xmlns:a16="http://schemas.microsoft.com/office/drawing/2014/main" id="{C7C32A34-CA46-D74D-AA45-2D38056245CF}"/>
+              <a:rPr lang="en-US" dirty="0"/>
+              <a:t>Precision-Recall </a:t>
+            </a:r>
+          </a:p>
+          <a:p>
+            <a:r>
+              <a:rPr lang="en-US" dirty="0"/>
+              <a:t>Curve</a:t>
+            </a:r>
+          </a:p>
+        </p:txBody>
+      </p:sp>
+      <p:sp>
+        <p:nvSpPr>
+          <p:cNvPr id="9" name="TextBox 8">
+            <a:extLst>
+              <a:ext uri="{FF2B5EF4-FFF2-40B4-BE49-F238E27FC236}">
+                <a16:creationId xmlns:a16="http://schemas.microsoft.com/office/drawing/2014/main" id="{F7824489-5BB9-F74D-8592-EA7D0BAD26C8}"/>
               </a:ext>
             </a:extLst>
           </p:cNvPr>
@@ -6272,9 +6131,9 @@
           <p:nvPr/>
         </p:nvSpPr>
         <p:spPr>
-          <a:xfrm rot="18665804">
-            <a:off x="6655239" y="429809"/>
-            <a:ext cx="673700" cy="307777"/>
+          <a:xfrm>
+            <a:off x="8552082" y="4225255"/>
+            <a:ext cx="914400" cy="230832"/>
           </a:xfrm>
           <a:prstGeom prst="rect">
             <a:avLst/>
@@ -6288,6 +6147,76 @@
           <a:lstStyle/>
           <a:p>
             <a:r>
+              <a:rPr lang="en-US" sz="900" b="1" dirty="0"/>
+              <a:t>Low Threshold</a:t>
+            </a:r>
+          </a:p>
+        </p:txBody>
+      </p:sp>
+      <p:sp>
+        <p:nvSpPr>
+          <p:cNvPr id="14" name="TextBox 13">
+            <a:extLst>
+              <a:ext uri="{FF2B5EF4-FFF2-40B4-BE49-F238E27FC236}">
+                <a16:creationId xmlns:a16="http://schemas.microsoft.com/office/drawing/2014/main" id="{13DD589D-266C-6547-AFFF-F661F1CA7BE7}"/>
+              </a:ext>
+            </a:extLst>
+          </p:cNvPr>
+          <p:cNvSpPr txBox="1"/>
+          <p:nvPr/>
+        </p:nvSpPr>
+        <p:spPr>
+          <a:xfrm>
+            <a:off x="7242071" y="6023419"/>
+            <a:ext cx="914400" cy="230832"/>
+          </a:xfrm>
+          <a:prstGeom prst="rect">
+            <a:avLst/>
+          </a:prstGeom>
+          <a:noFill/>
+        </p:spPr>
+        <p:txBody>
+          <a:bodyPr wrap="square" rtlCol="0">
+            <a:spAutoFit/>
+          </a:bodyPr>
+          <a:lstStyle/>
+          <a:p>
+            <a:r>
+              <a:rPr lang="en-US" sz="900" b="1" dirty="0"/>
+              <a:t>High Threshold</a:t>
+            </a:r>
+          </a:p>
+        </p:txBody>
+      </p:sp>
+      <p:sp>
+        <p:nvSpPr>
+          <p:cNvPr id="12" name="TextBox 11">
+            <a:extLst>
+              <a:ext uri="{FF2B5EF4-FFF2-40B4-BE49-F238E27FC236}">
+                <a16:creationId xmlns:a16="http://schemas.microsoft.com/office/drawing/2014/main" id="{C7C32A34-CA46-D74D-AA45-2D38056245CF}"/>
+              </a:ext>
+            </a:extLst>
+          </p:cNvPr>
+          <p:cNvSpPr txBox="1"/>
+          <p:nvPr/>
+        </p:nvSpPr>
+        <p:spPr>
+          <a:xfrm rot="18665804">
+            <a:off x="6593460" y="4186782"/>
+            <a:ext cx="673700" cy="307777"/>
+          </a:xfrm>
+          <a:prstGeom prst="rect">
+            <a:avLst/>
+          </a:prstGeom>
+          <a:noFill/>
+        </p:spPr>
+        <p:txBody>
+          <a:bodyPr wrap="square" rtlCol="0">
+            <a:spAutoFit/>
+          </a:bodyPr>
+          <a:lstStyle/>
+          <a:p>
+            <a:r>
               <a:rPr lang="en-US" sz="1400" dirty="0">
                 <a:solidFill>
                   <a:srgbClr val="0070C0"/>
@@ -6312,7 +6241,7 @@
         </p:nvSpPr>
         <p:spPr>
           <a:xfrm rot="18665804">
-            <a:off x="8975833" y="2613420"/>
+            <a:off x="8914054" y="6370393"/>
             <a:ext cx="462463" cy="307777"/>
           </a:xfrm>
           <a:prstGeom prst="rect">
@@ -6337,6 +6266,343 @@
           </a:p>
         </p:txBody>
       </p:sp>
+      <p:sp>
+        <p:nvSpPr>
+          <p:cNvPr id="17" name="TextBox 16">
+            <a:extLst>
+              <a:ext uri="{FF2B5EF4-FFF2-40B4-BE49-F238E27FC236}">
+                <a16:creationId xmlns:a16="http://schemas.microsoft.com/office/drawing/2014/main" id="{D6E63C8F-DBAC-0D4F-B95D-B7BF5F88B633}"/>
+              </a:ext>
+            </a:extLst>
+          </p:cNvPr>
+          <p:cNvSpPr txBox="1"/>
+          <p:nvPr/>
+        </p:nvSpPr>
+        <p:spPr>
+          <a:xfrm>
+            <a:off x="7589251" y="1341021"/>
+            <a:ext cx="907178" cy="369332"/>
+          </a:xfrm>
+          <a:prstGeom prst="rect">
+            <a:avLst/>
+          </a:prstGeom>
+          <a:noFill/>
+        </p:spPr>
+        <p:txBody>
+          <a:bodyPr wrap="square" rtlCol="0">
+            <a:spAutoFit/>
+          </a:bodyPr>
+          <a:lstStyle/>
+          <a:p>
+            <a:r>
+              <a:rPr lang="en-US" b="1" dirty="0">
+                <a:solidFill>
+                  <a:srgbClr val="0070C0"/>
+                </a:solidFill>
+              </a:rPr>
+              <a:t>Planes</a:t>
+            </a:r>
+          </a:p>
+        </p:txBody>
+      </p:sp>
+      <p:sp>
+        <p:nvSpPr>
+          <p:cNvPr id="19" name="TextBox 18">
+            <a:extLst>
+              <a:ext uri="{FF2B5EF4-FFF2-40B4-BE49-F238E27FC236}">
+                <a16:creationId xmlns:a16="http://schemas.microsoft.com/office/drawing/2014/main" id="{0FC215BA-CEB4-F646-8283-171497A3B440}"/>
+              </a:ext>
+            </a:extLst>
+          </p:cNvPr>
+          <p:cNvSpPr txBox="1"/>
+          <p:nvPr/>
+        </p:nvSpPr>
+        <p:spPr>
+          <a:xfrm>
+            <a:off x="7623464" y="1929204"/>
+            <a:ext cx="907178" cy="369332"/>
+          </a:xfrm>
+          <a:prstGeom prst="rect">
+            <a:avLst/>
+          </a:prstGeom>
+          <a:noFill/>
+        </p:spPr>
+        <p:txBody>
+          <a:bodyPr wrap="square" rtlCol="0">
+            <a:spAutoFit/>
+          </a:bodyPr>
+          <a:lstStyle/>
+          <a:p>
+            <a:r>
+              <a:rPr lang="en-US" b="1" dirty="0">
+                <a:solidFill>
+                  <a:srgbClr val="0070C0"/>
+                </a:solidFill>
+              </a:rPr>
+              <a:t>Noise</a:t>
+            </a:r>
+          </a:p>
+        </p:txBody>
+      </p:sp>
+      <p:sp>
+        <p:nvSpPr>
+          <p:cNvPr id="18" name="Right Arrow 17">
+            <a:extLst>
+              <a:ext uri="{FF2B5EF4-FFF2-40B4-BE49-F238E27FC236}">
+                <a16:creationId xmlns:a16="http://schemas.microsoft.com/office/drawing/2014/main" id="{A10EDF36-1734-F945-8DCD-FB34895AD268}"/>
+              </a:ext>
+            </a:extLst>
+          </p:cNvPr>
+          <p:cNvSpPr/>
+          <p:nvPr/>
+        </p:nvSpPr>
+        <p:spPr>
+          <a:xfrm>
+            <a:off x="8540652" y="1468537"/>
+            <a:ext cx="593203" cy="184666"/>
+          </a:xfrm>
+          <a:prstGeom prst="rightArrow">
+            <a:avLst/>
+          </a:prstGeom>
+        </p:spPr>
+        <p:style>
+          <a:lnRef idx="2">
+            <a:schemeClr val="accent1">
+              <a:shade val="50000"/>
+            </a:schemeClr>
+          </a:lnRef>
+          <a:fillRef idx="1">
+            <a:schemeClr val="accent1"/>
+          </a:fillRef>
+          <a:effectRef idx="0">
+            <a:schemeClr val="accent1"/>
+          </a:effectRef>
+          <a:fontRef idx="minor">
+            <a:schemeClr val="lt1"/>
+          </a:fontRef>
+        </p:style>
+        <p:txBody>
+          <a:bodyPr rtlCol="0" anchor="ctr"/>
+          <a:lstStyle/>
+          <a:p>
+            <a:pPr algn="ctr"/>
+            <a:endParaRPr lang="en-US"/>
+          </a:p>
+        </p:txBody>
+      </p:sp>
+      <p:sp>
+        <p:nvSpPr>
+          <p:cNvPr id="21" name="Right Arrow 20">
+            <a:extLst>
+              <a:ext uri="{FF2B5EF4-FFF2-40B4-BE49-F238E27FC236}">
+                <a16:creationId xmlns:a16="http://schemas.microsoft.com/office/drawing/2014/main" id="{7F2190E6-265D-ED48-BC74-67E8CDE44D05}"/>
+              </a:ext>
+            </a:extLst>
+          </p:cNvPr>
+          <p:cNvSpPr/>
+          <p:nvPr/>
+        </p:nvSpPr>
+        <p:spPr>
+          <a:xfrm>
+            <a:off x="8533032" y="2043847"/>
+            <a:ext cx="593203" cy="184666"/>
+          </a:xfrm>
+          <a:prstGeom prst="rightArrow">
+            <a:avLst/>
+          </a:prstGeom>
+        </p:spPr>
+        <p:style>
+          <a:lnRef idx="2">
+            <a:schemeClr val="accent1">
+              <a:shade val="50000"/>
+            </a:schemeClr>
+          </a:lnRef>
+          <a:fillRef idx="1">
+            <a:schemeClr val="accent1"/>
+          </a:fillRef>
+          <a:effectRef idx="0">
+            <a:schemeClr val="accent1"/>
+          </a:effectRef>
+          <a:fontRef idx="minor">
+            <a:schemeClr val="lt1"/>
+          </a:fontRef>
+        </p:style>
+        <p:txBody>
+          <a:bodyPr rtlCol="0" anchor="ctr"/>
+          <a:lstStyle/>
+          <a:p>
+            <a:pPr algn="ctr"/>
+            <a:endParaRPr lang="en-US"/>
+          </a:p>
+        </p:txBody>
+      </p:sp>
+      <p:pic>
+        <p:nvPicPr>
+          <p:cNvPr id="22" name="Picture 21">
+            <a:extLst>
+              <a:ext uri="{FF2B5EF4-FFF2-40B4-BE49-F238E27FC236}">
+                <a16:creationId xmlns:a16="http://schemas.microsoft.com/office/drawing/2014/main" id="{77283C55-8993-994C-A8BE-5032944D0F0D}"/>
+              </a:ext>
+            </a:extLst>
+          </p:cNvPr>
+          <p:cNvPicPr>
+            <a:picLocks noChangeAspect="1"/>
+          </p:cNvPicPr>
+          <p:nvPr/>
+        </p:nvPicPr>
+        <p:blipFill>
+          <a:blip r:embed="rId5" cstate="email">
+            <a:extLst>
+              <a:ext uri="{28A0092B-C50C-407E-A947-70E740481C1C}">
+                <a14:useLocalDpi xmlns:a14="http://schemas.microsoft.com/office/drawing/2010/main"/>
+              </a:ext>
+            </a:extLst>
+          </a:blip>
+          <a:stretch>
+            <a:fillRect/>
+          </a:stretch>
+        </p:blipFill>
+        <p:spPr>
+          <a:xfrm>
+            <a:off x="9572224" y="46353"/>
+            <a:ext cx="2113226" cy="954220"/>
+          </a:xfrm>
+          <a:prstGeom prst="rect">
+            <a:avLst/>
+          </a:prstGeom>
+        </p:spPr>
+      </p:pic>
+      <p:sp>
+        <p:nvSpPr>
+          <p:cNvPr id="25" name="TextBox 24">
+            <a:extLst>
+              <a:ext uri="{FF2B5EF4-FFF2-40B4-BE49-F238E27FC236}">
+                <a16:creationId xmlns:a16="http://schemas.microsoft.com/office/drawing/2014/main" id="{C6EFCEE2-B8F0-D845-AD64-D7DF33CEA1F6}"/>
+              </a:ext>
+            </a:extLst>
+          </p:cNvPr>
+          <p:cNvSpPr txBox="1"/>
+          <p:nvPr/>
+        </p:nvSpPr>
+        <p:spPr>
+          <a:xfrm>
+            <a:off x="7061548" y="2835889"/>
+            <a:ext cx="2128172" cy="377582"/>
+          </a:xfrm>
+          <a:prstGeom prst="rect">
+            <a:avLst/>
+          </a:prstGeom>
+          <a:noFill/>
+        </p:spPr>
+        <p:txBody>
+          <a:bodyPr wrap="square" rtlCol="0">
+            <a:spAutoFit/>
+          </a:bodyPr>
+          <a:lstStyle/>
+          <a:p>
+            <a:r>
+              <a:rPr lang="en-US" b="1" dirty="0">
+                <a:solidFill>
+                  <a:srgbClr val="FF0000"/>
+                </a:solidFill>
+              </a:rPr>
+              <a:t>Selecting Threshold</a:t>
+            </a:r>
+          </a:p>
+        </p:txBody>
+      </p:sp>
+      <p:sp>
+        <p:nvSpPr>
+          <p:cNvPr id="26" name="TextBox 25">
+            <a:extLst>
+              <a:ext uri="{FF2B5EF4-FFF2-40B4-BE49-F238E27FC236}">
+                <a16:creationId xmlns:a16="http://schemas.microsoft.com/office/drawing/2014/main" id="{4EC0EFC6-BE5C-3942-B979-AD154D7DC586}"/>
+              </a:ext>
+            </a:extLst>
+          </p:cNvPr>
+          <p:cNvSpPr txBox="1"/>
+          <p:nvPr/>
+        </p:nvSpPr>
+        <p:spPr>
+          <a:xfrm>
+            <a:off x="6534143" y="58306"/>
+            <a:ext cx="2733960" cy="923330"/>
+          </a:xfrm>
+          <a:prstGeom prst="rect">
+            <a:avLst/>
+          </a:prstGeom>
+          <a:noFill/>
+        </p:spPr>
+        <p:txBody>
+          <a:bodyPr wrap="square" rtlCol="0">
+            <a:spAutoFit/>
+          </a:bodyPr>
+          <a:lstStyle/>
+          <a:p>
+            <a:r>
+              <a:rPr lang="en-US" dirty="0"/>
+              <a:t>Radar detects planes.</a:t>
+            </a:r>
+          </a:p>
+          <a:p>
+            <a:r>
+              <a:rPr lang="en-US" dirty="0"/>
+              <a:t>It need to separate</a:t>
+            </a:r>
+          </a:p>
+          <a:p>
+            <a:r>
+              <a:rPr lang="en-US" dirty="0"/>
+              <a:t>"plane" signals from noise.</a:t>
+            </a:r>
+          </a:p>
+        </p:txBody>
+      </p:sp>
+      <p:pic>
+        <p:nvPicPr>
+          <p:cNvPr id="1026" name="Picture 2">
+            <a:extLst>
+              <a:ext uri="{FF2B5EF4-FFF2-40B4-BE49-F238E27FC236}">
+                <a16:creationId xmlns:a16="http://schemas.microsoft.com/office/drawing/2014/main" id="{2BC20A43-B20A-C048-84DD-1B9000CBD431}"/>
+              </a:ext>
+            </a:extLst>
+          </p:cNvPr>
+          <p:cNvPicPr>
+            <a:picLocks noChangeAspect="1" noChangeArrowheads="1"/>
+          </p:cNvPicPr>
+          <p:nvPr/>
+        </p:nvPicPr>
+        <p:blipFill rotWithShape="1">
+          <a:blip r:embed="rId6" cstate="email">
+            <a:extLst>
+              <a:ext uri="{28A0092B-C50C-407E-A947-70E740481C1C}">
+                <a14:useLocalDpi xmlns:a14="http://schemas.microsoft.com/office/drawing/2010/main"/>
+              </a:ext>
+            </a:extLst>
+          </a:blip>
+          <a:srcRect/>
+          <a:stretch/>
+        </p:blipFill>
+        <p:spPr bwMode="auto">
+          <a:xfrm>
+            <a:off x="2778748" y="5882551"/>
+            <a:ext cx="2112554" cy="732636"/>
+          </a:xfrm>
+          <a:prstGeom prst="rect">
+            <a:avLst/>
+          </a:prstGeom>
+          <a:noFill/>
+          <a:extLst>
+            <a:ext uri="{909E8E84-426E-40DD-AFC4-6F175D3DCCD1}">
+              <a14:hiddenFill xmlns:a14="http://schemas.microsoft.com/office/drawing/2010/main">
+                <a:solidFill>
+                  <a:srgbClr val="FFFFFF"/>
+                </a:solidFill>
+              </a14:hiddenFill>
+            </a:ext>
+          </a:extLst>
+        </p:spPr>
+      </p:pic>
     </p:spTree>
     <p:extLst>
       <p:ext uri="{BB962C8B-B14F-4D97-AF65-F5344CB8AC3E}">
@@ -10895,7 +11161,7 @@
                 <a:cs typeface="Calibri"/>
                 <a:sym typeface="Calibri"/>
               </a:rPr>
-              <a:t>Why good ROC curve is above diagonal</a:t>
+              <a:t>Good ROC curve is above diagonal</a:t>
             </a:r>
             <a:endParaRPr dirty="0"/>
           </a:p>
@@ -10921,12 +11187,59 @@
           </a:p>
         </p:txBody>
       </p:sp>
+      <p:sp>
+        <p:nvSpPr>
+          <p:cNvPr id="7" name="TextBox 6">
+            <a:extLst>
+              <a:ext uri="{FF2B5EF4-FFF2-40B4-BE49-F238E27FC236}">
+                <a16:creationId xmlns:a16="http://schemas.microsoft.com/office/drawing/2014/main" id="{765B8119-CB34-004A-8BAF-2F2E2895F4D1}"/>
+              </a:ext>
+            </a:extLst>
+          </p:cNvPr>
+          <p:cNvSpPr txBox="1"/>
+          <p:nvPr/>
+        </p:nvSpPr>
+        <p:spPr>
+          <a:xfrm>
+            <a:off x="2635839" y="5550176"/>
+            <a:ext cx="5513751" cy="1015663"/>
+          </a:xfrm>
+          <a:prstGeom prst="rect">
+            <a:avLst/>
+          </a:prstGeom>
+          <a:noFill/>
+        </p:spPr>
+        <p:txBody>
+          <a:bodyPr wrap="square" rtlCol="0">
+            <a:spAutoFit/>
+          </a:bodyPr>
+          <a:lstStyle/>
+          <a:p>
+            <a:r>
+              <a:rPr lang="en-US" sz="2000" dirty="0"/>
+              <a:t>ROC curve axes:</a:t>
+            </a:r>
+          </a:p>
+          <a:p>
+            <a:r>
+              <a:rPr lang="en-US" sz="2000" dirty="0"/>
+              <a:t>   vertical      = True Positives  / All Actual Positives</a:t>
+            </a:r>
+          </a:p>
+          <a:p>
+            <a:r>
+              <a:rPr lang="en-US" sz="2000" dirty="0"/>
+              <a:t>   horizontal = False Positives / All Actual Negatives</a:t>
+            </a:r>
+          </a:p>
+        </p:txBody>
+      </p:sp>
       <p:pic>
         <p:nvPicPr>
-          <p:cNvPr id="3" name="Picture 2">
-            <a:extLst>
-              <a:ext uri="{FF2B5EF4-FFF2-40B4-BE49-F238E27FC236}">
-                <a16:creationId xmlns:a16="http://schemas.microsoft.com/office/drawing/2014/main" id="{4D8283FA-2D57-6143-BD4D-5E14DD32FD69}"/>
+          <p:cNvPr id="8" name="Picture 7">
+            <a:extLst>
+              <a:ext uri="{FF2B5EF4-FFF2-40B4-BE49-F238E27FC236}">
+                <a16:creationId xmlns:a16="http://schemas.microsoft.com/office/drawing/2014/main" id="{8009B122-E45E-DD45-B6AE-9B4303E6D32E}"/>
               </a:ext>
             </a:extLst>
           </p:cNvPr>
@@ -10936,37 +11249,7 @@
           <p:nvPr/>
         </p:nvPicPr>
         <p:blipFill>
-          <a:blip r:embed="rId3"/>
-          <a:stretch>
-            <a:fillRect/>
-          </a:stretch>
-        </p:blipFill>
-        <p:spPr>
-          <a:xfrm>
-            <a:off x="8727140" y="0"/>
-            <a:ext cx="3248213" cy="2817727"/>
-          </a:xfrm>
-          <a:prstGeom prst="rect">
-            <a:avLst/>
-          </a:prstGeom>
-        </p:spPr>
-      </p:pic>
-      <p:pic>
-        <p:nvPicPr>
-          <p:cNvPr id="5" name="Picture 4">
-            <a:extLst>
-              <a:ext uri="{FF2B5EF4-FFF2-40B4-BE49-F238E27FC236}">
-                <a16:creationId xmlns:a16="http://schemas.microsoft.com/office/drawing/2014/main" id="{FB4BAF2C-0C1A-F448-A098-8A465864D8DA}"/>
-              </a:ext>
-            </a:extLst>
-          </p:cNvPr>
-          <p:cNvPicPr>
-            <a:picLocks noChangeAspect="1"/>
-          </p:cNvPicPr>
-          <p:nvPr/>
-        </p:nvPicPr>
-        <p:blipFill>
-          <a:blip r:embed="rId4" cstate="email">
+          <a:blip r:embed="rId3" cstate="email">
             <a:extLst>
               <a:ext uri="{28A0092B-C50C-407E-A947-70E740481C1C}">
                 <a14:useLocalDpi xmlns:a14="http://schemas.microsoft.com/office/drawing/2010/main"/>
@@ -10979,90 +11262,7 @@
         </p:blipFill>
         <p:spPr>
           <a:xfrm>
-            <a:off x="6705600" y="3012140"/>
-            <a:ext cx="5486400" cy="3657600"/>
-          </a:xfrm>
-          <a:prstGeom prst="rect">
-            <a:avLst/>
-          </a:prstGeom>
-        </p:spPr>
-      </p:pic>
-      <p:sp>
-        <p:nvSpPr>
-          <p:cNvPr id="7" name="TextBox 6">
-            <a:extLst>
-              <a:ext uri="{FF2B5EF4-FFF2-40B4-BE49-F238E27FC236}">
-                <a16:creationId xmlns:a16="http://schemas.microsoft.com/office/drawing/2014/main" id="{765B8119-CB34-004A-8BAF-2F2E2895F4D1}"/>
-              </a:ext>
-            </a:extLst>
-          </p:cNvPr>
-          <p:cNvSpPr txBox="1"/>
-          <p:nvPr/>
-        </p:nvSpPr>
-        <p:spPr>
-          <a:xfrm>
-            <a:off x="738459" y="5413016"/>
-            <a:ext cx="6412951" cy="1015663"/>
-          </a:xfrm>
-          <a:prstGeom prst="rect">
-            <a:avLst/>
-          </a:prstGeom>
-          <a:noFill/>
-        </p:spPr>
-        <p:txBody>
-          <a:bodyPr wrap="square" rtlCol="0">
-            <a:spAutoFit/>
-          </a:bodyPr>
-          <a:lstStyle/>
-          <a:p>
-            <a:r>
-              <a:rPr lang="en-US" sz="2000" dirty="0"/>
-              <a:t>ROC curve axes:</a:t>
-            </a:r>
-          </a:p>
-          <a:p>
-            <a:r>
-              <a:rPr lang="en-US" sz="2000" dirty="0"/>
-              <a:t>   vertical      – True Positives  / All Actual Positives</a:t>
-            </a:r>
-          </a:p>
-          <a:p>
-            <a:r>
-              <a:rPr lang="en-US" sz="2000" dirty="0"/>
-              <a:t>   horizontal – False Positives / All Actual Negatives</a:t>
-            </a:r>
-          </a:p>
-        </p:txBody>
-      </p:sp>
-      <p:pic>
-        <p:nvPicPr>
-          <p:cNvPr id="8" name="Picture 7">
-            <a:extLst>
-              <a:ext uri="{FF2B5EF4-FFF2-40B4-BE49-F238E27FC236}">
-                <a16:creationId xmlns:a16="http://schemas.microsoft.com/office/drawing/2014/main" id="{8009B122-E45E-DD45-B6AE-9B4303E6D32E}"/>
-              </a:ext>
-            </a:extLst>
-          </p:cNvPr>
-          <p:cNvPicPr>
-            <a:picLocks noChangeAspect="1"/>
-          </p:cNvPicPr>
-          <p:nvPr/>
-        </p:nvPicPr>
-        <p:blipFill>
-          <a:blip r:embed="rId5" cstate="email">
-            <a:extLst>
-              <a:ext uri="{28A0092B-C50C-407E-A947-70E740481C1C}">
-                <a14:useLocalDpi xmlns:a14="http://schemas.microsoft.com/office/drawing/2010/main"/>
-              </a:ext>
-            </a:extLst>
-          </a:blip>
-          <a:stretch>
-            <a:fillRect/>
-          </a:stretch>
-        </p:blipFill>
-        <p:spPr>
-          <a:xfrm>
-            <a:off x="1658993" y="1767574"/>
+            <a:off x="3556373" y="1904734"/>
             <a:ext cx="3289300" cy="3378200"/>
           </a:xfrm>
           <a:prstGeom prst="rect">
@@ -11084,7 +11284,7 @@
         </p:nvCxnSpPr>
         <p:spPr>
           <a:xfrm flipV="1">
-            <a:off x="2333081" y="1931926"/>
+            <a:off x="4230461" y="2069086"/>
             <a:ext cx="2547976" cy="2608289"/>
           </a:xfrm>
           <a:prstGeom prst="line">
@@ -11125,7 +11325,7 @@
         </p:nvSpPr>
         <p:spPr>
           <a:xfrm>
-            <a:off x="1159851" y="1881459"/>
+            <a:off x="3272309" y="1873719"/>
             <a:ext cx="736706" cy="369332"/>
           </a:xfrm>
           <a:prstGeom prst="rect">
@@ -11141,7 +11341,7 @@
           <a:p>
             <a:r>
               <a:rPr lang="en-US" dirty="0"/>
-              <a:t>TP/AP</a:t>
+              <a:t>TP/P</a:t>
             </a:r>
           </a:p>
         </p:txBody>
@@ -11160,7 +11360,7 @@
         </p:nvSpPr>
         <p:spPr>
           <a:xfrm>
-            <a:off x="4761465" y="4807457"/>
+            <a:off x="6658845" y="4944617"/>
             <a:ext cx="960225" cy="369332"/>
           </a:xfrm>
           <a:prstGeom prst="rect">
@@ -11176,17 +11376,57 @@
           <a:p>
             <a:r>
               <a:rPr lang="en-US" dirty="0"/>
-              <a:t>FP/AN</a:t>
-            </a:r>
-          </a:p>
-        </p:txBody>
-      </p:sp>
-      <p:sp>
-        <p:nvSpPr>
-          <p:cNvPr id="4" name="Freeform 3">
-            <a:extLst>
-              <a:ext uri="{FF2B5EF4-FFF2-40B4-BE49-F238E27FC236}">
-                <a16:creationId xmlns:a16="http://schemas.microsoft.com/office/drawing/2014/main" id="{B24DAC1B-FBF6-0943-BEA2-5008D7750A17}"/>
+              <a:t>FP/N</a:t>
+            </a:r>
+          </a:p>
+        </p:txBody>
+      </p:sp>
+      <p:sp>
+        <p:nvSpPr>
+          <p:cNvPr id="2" name="TextBox 1">
+            <a:extLst>
+              <a:ext uri="{FF2B5EF4-FFF2-40B4-BE49-F238E27FC236}">
+                <a16:creationId xmlns:a16="http://schemas.microsoft.com/office/drawing/2014/main" id="{1D453D8E-97EC-B844-9AB6-8B1C082342BA}"/>
+              </a:ext>
+            </a:extLst>
+          </p:cNvPr>
+          <p:cNvSpPr txBox="1"/>
+          <p:nvPr/>
+        </p:nvSpPr>
+        <p:spPr>
+          <a:xfrm>
+            <a:off x="7435472" y="1756076"/>
+            <a:ext cx="1953592" cy="461665"/>
+          </a:xfrm>
+          <a:prstGeom prst="rect">
+            <a:avLst/>
+          </a:prstGeom>
+          <a:solidFill>
+            <a:schemeClr val="accent4">
+              <a:lumMod val="20000"/>
+              <a:lumOff val="80000"/>
+            </a:schemeClr>
+          </a:solidFill>
+        </p:spPr>
+        <p:txBody>
+          <a:bodyPr wrap="square" rtlCol="0">
+            <a:spAutoFit/>
+          </a:bodyPr>
+          <a:lstStyle/>
+          <a:p>
+            <a:r>
+              <a:rPr lang="en-US" sz="1200" dirty="0"/>
+              <a:t>Low Threshold – detect all events and all noise</a:t>
+            </a:r>
+          </a:p>
+        </p:txBody>
+      </p:sp>
+      <p:sp>
+        <p:nvSpPr>
+          <p:cNvPr id="6" name="Left Arrow 5">
+            <a:extLst>
+              <a:ext uri="{FF2B5EF4-FFF2-40B4-BE49-F238E27FC236}">
+                <a16:creationId xmlns:a16="http://schemas.microsoft.com/office/drawing/2014/main" id="{56DF35C6-4E73-8541-946F-E8674CE5FF32}"/>
               </a:ext>
             </a:extLst>
           </p:cNvPr>
@@ -11195,124 +11435,12 @@
         </p:nvSpPr>
         <p:spPr>
           <a:xfrm>
-            <a:off x="9495693" y="1635308"/>
-            <a:ext cx="2603380" cy="47792"/>
-          </a:xfrm>
-          <a:custGeom>
+            <a:off x="7008367" y="1904734"/>
+            <a:ext cx="387626" cy="164351"/>
+          </a:xfrm>
+          <a:prstGeom prst="leftArrow">
             <a:avLst/>
-            <a:gdLst>
-              <a:gd name="connsiteX0" fmla="*/ 0 w 2501462"/>
-              <a:gd name="connsiteY0" fmla="*/ 157675 h 157675"/>
-              <a:gd name="connsiteX1" fmla="*/ 262759 w 2501462"/>
-              <a:gd name="connsiteY1" fmla="*/ 52571 h 157675"/>
-              <a:gd name="connsiteX2" fmla="*/ 536028 w 2501462"/>
-              <a:gd name="connsiteY2" fmla="*/ 147164 h 157675"/>
-              <a:gd name="connsiteX3" fmla="*/ 767256 w 2501462"/>
-              <a:gd name="connsiteY3" fmla="*/ 42061 h 157675"/>
-              <a:gd name="connsiteX4" fmla="*/ 1166649 w 2501462"/>
-              <a:gd name="connsiteY4" fmla="*/ 115633 h 157675"/>
-              <a:gd name="connsiteX5" fmla="*/ 1534511 w 2501462"/>
-              <a:gd name="connsiteY5" fmla="*/ 20 h 157675"/>
-              <a:gd name="connsiteX6" fmla="*/ 1828800 w 2501462"/>
-              <a:gd name="connsiteY6" fmla="*/ 126144 h 157675"/>
-              <a:gd name="connsiteX7" fmla="*/ 2154621 w 2501462"/>
-              <a:gd name="connsiteY7" fmla="*/ 42061 h 157675"/>
-              <a:gd name="connsiteX8" fmla="*/ 2501462 w 2501462"/>
-              <a:gd name="connsiteY8" fmla="*/ 136654 h 157675"/>
-              <a:gd name="connsiteX9" fmla="*/ 2501462 w 2501462"/>
-              <a:gd name="connsiteY9" fmla="*/ 136654 h 157675"/>
-            </a:gdLst>
-            <a:ahLst/>
-            <a:cxnLst>
-              <a:cxn ang="0">
-                <a:pos x="connsiteX0" y="connsiteY0"/>
-              </a:cxn>
-              <a:cxn ang="0">
-                <a:pos x="connsiteX1" y="connsiteY1"/>
-              </a:cxn>
-              <a:cxn ang="0">
-                <a:pos x="connsiteX2" y="connsiteY2"/>
-              </a:cxn>
-              <a:cxn ang="0">
-                <a:pos x="connsiteX3" y="connsiteY3"/>
-              </a:cxn>
-              <a:cxn ang="0">
-                <a:pos x="connsiteX4" y="connsiteY4"/>
-              </a:cxn>
-              <a:cxn ang="0">
-                <a:pos x="connsiteX5" y="connsiteY5"/>
-              </a:cxn>
-              <a:cxn ang="0">
-                <a:pos x="connsiteX6" y="connsiteY6"/>
-              </a:cxn>
-              <a:cxn ang="0">
-                <a:pos x="connsiteX7" y="connsiteY7"/>
-              </a:cxn>
-              <a:cxn ang="0">
-                <a:pos x="connsiteX8" y="connsiteY8"/>
-              </a:cxn>
-              <a:cxn ang="0">
-                <a:pos x="connsiteX9" y="connsiteY9"/>
-              </a:cxn>
-            </a:cxnLst>
-            <a:rect l="l" t="t" r="r" b="b"/>
-            <a:pathLst>
-              <a:path w="2501462" h="157675">
-                <a:moveTo>
-                  <a:pt x="0" y="157675"/>
-                </a:moveTo>
-                <a:cubicBezTo>
-                  <a:pt x="86710" y="105999"/>
-                  <a:pt x="173421" y="54323"/>
-                  <a:pt x="262759" y="52571"/>
-                </a:cubicBezTo>
-                <a:cubicBezTo>
-                  <a:pt x="352097" y="50819"/>
-                  <a:pt x="451945" y="148916"/>
-                  <a:pt x="536028" y="147164"/>
-                </a:cubicBezTo>
-                <a:cubicBezTo>
-                  <a:pt x="620111" y="145412"/>
-                  <a:pt x="662153" y="47316"/>
-                  <a:pt x="767256" y="42061"/>
-                </a:cubicBezTo>
-                <a:cubicBezTo>
-                  <a:pt x="872359" y="36806"/>
-                  <a:pt x="1038773" y="122640"/>
-                  <a:pt x="1166649" y="115633"/>
-                </a:cubicBezTo>
-                <a:cubicBezTo>
-                  <a:pt x="1294525" y="108626"/>
-                  <a:pt x="1424153" y="-1732"/>
-                  <a:pt x="1534511" y="20"/>
-                </a:cubicBezTo>
-                <a:cubicBezTo>
-                  <a:pt x="1644869" y="1772"/>
-                  <a:pt x="1725448" y="119137"/>
-                  <a:pt x="1828800" y="126144"/>
-                </a:cubicBezTo>
-                <a:cubicBezTo>
-                  <a:pt x="1932152" y="133151"/>
-                  <a:pt x="2042511" y="40309"/>
-                  <a:pt x="2154621" y="42061"/>
-                </a:cubicBezTo>
-                <a:cubicBezTo>
-                  <a:pt x="2266731" y="43813"/>
-                  <a:pt x="2501462" y="136654"/>
-                  <a:pt x="2501462" y="136654"/>
-                </a:cubicBezTo>
-                <a:lnTo>
-                  <a:pt x="2501462" y="136654"/>
-                </a:lnTo>
-              </a:path>
-            </a:pathLst>
-          </a:custGeom>
-          <a:noFill/>
-          <a:ln w="63500">
-            <a:solidFill>
-              <a:srgbClr val="FF0000"/>
-            </a:solidFill>
-          </a:ln>
+          </a:prstGeom>
         </p:spPr>
         <p:style>
           <a:lnRef idx="2">
@@ -11341,10 +11469,62 @@
       </p:sp>
       <p:sp>
         <p:nvSpPr>
-          <p:cNvPr id="12" name="Freeform 11">
-            <a:extLst>
-              <a:ext uri="{FF2B5EF4-FFF2-40B4-BE49-F238E27FC236}">
-                <a16:creationId xmlns:a16="http://schemas.microsoft.com/office/drawing/2014/main" id="{E750A36C-A42B-9646-91FF-B37D28203DE5}"/>
+          <p:cNvPr id="14" name="TextBox 13">
+            <a:extLst>
+              <a:ext uri="{FF2B5EF4-FFF2-40B4-BE49-F238E27FC236}">
+                <a16:creationId xmlns:a16="http://schemas.microsoft.com/office/drawing/2014/main" id="{DBBFF551-180F-734A-B901-FC313A28660E}"/>
+              </a:ext>
+            </a:extLst>
+          </p:cNvPr>
+          <p:cNvSpPr txBox="1"/>
+          <p:nvPr/>
+        </p:nvSpPr>
+        <p:spPr>
+          <a:xfrm>
+            <a:off x="1893780" y="4421204"/>
+            <a:ext cx="1532871" cy="646331"/>
+          </a:xfrm>
+          <a:prstGeom prst="rect">
+            <a:avLst/>
+          </a:prstGeom>
+          <a:solidFill>
+            <a:schemeClr val="accent4">
+              <a:lumMod val="20000"/>
+              <a:lumOff val="80000"/>
+            </a:schemeClr>
+          </a:solidFill>
+        </p:spPr>
+        <p:txBody>
+          <a:bodyPr wrap="square" rtlCol="0">
+            <a:spAutoFit/>
+          </a:bodyPr>
+          <a:lstStyle/>
+          <a:p>
+            <a:r>
+              <a:rPr lang="en-US" sz="1200" dirty="0"/>
+              <a:t>Very high threshold.</a:t>
+            </a:r>
+          </a:p>
+          <a:p>
+            <a:r>
+              <a:rPr lang="en-US" sz="1200" dirty="0"/>
+              <a:t>Cut off all noise – and</a:t>
+            </a:r>
+          </a:p>
+          <a:p>
+            <a:r>
+              <a:rPr lang="en-US" sz="1200" dirty="0"/>
+              <a:t>most of "planes"</a:t>
+            </a:r>
+          </a:p>
+        </p:txBody>
+      </p:sp>
+      <p:sp>
+        <p:nvSpPr>
+          <p:cNvPr id="15" name="Left Arrow 14">
+            <a:extLst>
+              <a:ext uri="{FF2B5EF4-FFF2-40B4-BE49-F238E27FC236}">
+                <a16:creationId xmlns:a16="http://schemas.microsoft.com/office/drawing/2014/main" id="{BE0B01BA-4201-3045-B184-5387CC2DCB66}"/>
               </a:ext>
             </a:extLst>
           </p:cNvPr>
@@ -11352,125 +11532,13 @@
           <p:nvPr/>
         </p:nvSpPr>
         <p:spPr>
-          <a:xfrm rot="18803495" flipV="1">
-            <a:off x="7109791" y="4617011"/>
-            <a:ext cx="5123828" cy="126586"/>
-          </a:xfrm>
-          <a:custGeom>
+          <a:xfrm rot="16438469">
+            <a:off x="4291707" y="1753130"/>
+            <a:ext cx="567517" cy="120728"/>
+          </a:xfrm>
+          <a:prstGeom prst="leftArrow">
             <a:avLst/>
-            <a:gdLst>
-              <a:gd name="connsiteX0" fmla="*/ 0 w 2501462"/>
-              <a:gd name="connsiteY0" fmla="*/ 157675 h 157675"/>
-              <a:gd name="connsiteX1" fmla="*/ 262759 w 2501462"/>
-              <a:gd name="connsiteY1" fmla="*/ 52571 h 157675"/>
-              <a:gd name="connsiteX2" fmla="*/ 536028 w 2501462"/>
-              <a:gd name="connsiteY2" fmla="*/ 147164 h 157675"/>
-              <a:gd name="connsiteX3" fmla="*/ 767256 w 2501462"/>
-              <a:gd name="connsiteY3" fmla="*/ 42061 h 157675"/>
-              <a:gd name="connsiteX4" fmla="*/ 1166649 w 2501462"/>
-              <a:gd name="connsiteY4" fmla="*/ 115633 h 157675"/>
-              <a:gd name="connsiteX5" fmla="*/ 1534511 w 2501462"/>
-              <a:gd name="connsiteY5" fmla="*/ 20 h 157675"/>
-              <a:gd name="connsiteX6" fmla="*/ 1828800 w 2501462"/>
-              <a:gd name="connsiteY6" fmla="*/ 126144 h 157675"/>
-              <a:gd name="connsiteX7" fmla="*/ 2154621 w 2501462"/>
-              <a:gd name="connsiteY7" fmla="*/ 42061 h 157675"/>
-              <a:gd name="connsiteX8" fmla="*/ 2501462 w 2501462"/>
-              <a:gd name="connsiteY8" fmla="*/ 136654 h 157675"/>
-              <a:gd name="connsiteX9" fmla="*/ 2501462 w 2501462"/>
-              <a:gd name="connsiteY9" fmla="*/ 136654 h 157675"/>
-            </a:gdLst>
-            <a:ahLst/>
-            <a:cxnLst>
-              <a:cxn ang="0">
-                <a:pos x="connsiteX0" y="connsiteY0"/>
-              </a:cxn>
-              <a:cxn ang="0">
-                <a:pos x="connsiteX1" y="connsiteY1"/>
-              </a:cxn>
-              <a:cxn ang="0">
-                <a:pos x="connsiteX2" y="connsiteY2"/>
-              </a:cxn>
-              <a:cxn ang="0">
-                <a:pos x="connsiteX3" y="connsiteY3"/>
-              </a:cxn>
-              <a:cxn ang="0">
-                <a:pos x="connsiteX4" y="connsiteY4"/>
-              </a:cxn>
-              <a:cxn ang="0">
-                <a:pos x="connsiteX5" y="connsiteY5"/>
-              </a:cxn>
-              <a:cxn ang="0">
-                <a:pos x="connsiteX6" y="connsiteY6"/>
-              </a:cxn>
-              <a:cxn ang="0">
-                <a:pos x="connsiteX7" y="connsiteY7"/>
-              </a:cxn>
-              <a:cxn ang="0">
-                <a:pos x="connsiteX8" y="connsiteY8"/>
-              </a:cxn>
-              <a:cxn ang="0">
-                <a:pos x="connsiteX9" y="connsiteY9"/>
-              </a:cxn>
-            </a:cxnLst>
-            <a:rect l="l" t="t" r="r" b="b"/>
-            <a:pathLst>
-              <a:path w="2501462" h="157675">
-                <a:moveTo>
-                  <a:pt x="0" y="157675"/>
-                </a:moveTo>
-                <a:cubicBezTo>
-                  <a:pt x="86710" y="105999"/>
-                  <a:pt x="173421" y="54323"/>
-                  <a:pt x="262759" y="52571"/>
-                </a:cubicBezTo>
-                <a:cubicBezTo>
-                  <a:pt x="352097" y="50819"/>
-                  <a:pt x="451945" y="148916"/>
-                  <a:pt x="536028" y="147164"/>
-                </a:cubicBezTo>
-                <a:cubicBezTo>
-                  <a:pt x="620111" y="145412"/>
-                  <a:pt x="662153" y="47316"/>
-                  <a:pt x="767256" y="42061"/>
-                </a:cubicBezTo>
-                <a:cubicBezTo>
-                  <a:pt x="872359" y="36806"/>
-                  <a:pt x="1038773" y="122640"/>
-                  <a:pt x="1166649" y="115633"/>
-                </a:cubicBezTo>
-                <a:cubicBezTo>
-                  <a:pt x="1294525" y="108626"/>
-                  <a:pt x="1424153" y="-1732"/>
-                  <a:pt x="1534511" y="20"/>
-                </a:cubicBezTo>
-                <a:cubicBezTo>
-                  <a:pt x="1644869" y="1772"/>
-                  <a:pt x="1725448" y="119137"/>
-                  <a:pt x="1828800" y="126144"/>
-                </a:cubicBezTo>
-                <a:cubicBezTo>
-                  <a:pt x="1932152" y="133151"/>
-                  <a:pt x="2042511" y="40309"/>
-                  <a:pt x="2154621" y="42061"/>
-                </a:cubicBezTo>
-                <a:cubicBezTo>
-                  <a:pt x="2266731" y="43813"/>
-                  <a:pt x="2501462" y="136654"/>
-                  <a:pt x="2501462" y="136654"/>
-                </a:cubicBezTo>
-                <a:lnTo>
-                  <a:pt x="2501462" y="136654"/>
-                </a:lnTo>
-              </a:path>
-            </a:pathLst>
-          </a:custGeom>
-          <a:noFill/>
-          <a:ln w="63500">
-            <a:solidFill>
-              <a:srgbClr val="FF0000"/>
-            </a:solidFill>
-          </a:ln>
+          </a:prstGeom>
         </p:spPr>
         <p:style>
           <a:lnRef idx="2">
@@ -11499,50 +11567,10 @@
       </p:sp>
       <p:sp>
         <p:nvSpPr>
-          <p:cNvPr id="2" name="TextBox 1">
-            <a:extLst>
-              <a:ext uri="{FF2B5EF4-FFF2-40B4-BE49-F238E27FC236}">
-                <a16:creationId xmlns:a16="http://schemas.microsoft.com/office/drawing/2014/main" id="{1D453D8E-97EC-B844-9AB6-8B1C082342BA}"/>
-              </a:ext>
-            </a:extLst>
-          </p:cNvPr>
-          <p:cNvSpPr txBox="1"/>
-          <p:nvPr/>
-        </p:nvSpPr>
-        <p:spPr>
-          <a:xfrm>
-            <a:off x="5538092" y="1618916"/>
-            <a:ext cx="1953592" cy="461665"/>
-          </a:xfrm>
-          <a:prstGeom prst="rect">
-            <a:avLst/>
-          </a:prstGeom>
-          <a:solidFill>
-            <a:schemeClr val="accent4">
-              <a:lumMod val="20000"/>
-              <a:lumOff val="80000"/>
-            </a:schemeClr>
-          </a:solidFill>
-        </p:spPr>
-        <p:txBody>
-          <a:bodyPr wrap="square" rtlCol="0">
-            <a:spAutoFit/>
-          </a:bodyPr>
-          <a:lstStyle/>
-          <a:p>
-            <a:r>
-              <a:rPr lang="en-US" sz="1200" dirty="0"/>
-              <a:t>Low Threshold – detect all events and all noise</a:t>
-            </a:r>
-          </a:p>
-        </p:txBody>
-      </p:sp>
-      <p:sp>
-        <p:nvSpPr>
-          <p:cNvPr id="6" name="Left Arrow 5">
-            <a:extLst>
-              <a:ext uri="{FF2B5EF4-FFF2-40B4-BE49-F238E27FC236}">
-                <a16:creationId xmlns:a16="http://schemas.microsoft.com/office/drawing/2014/main" id="{56DF35C6-4E73-8541-946F-E8674CE5FF32}"/>
+          <p:cNvPr id="16" name="Left Arrow 15">
+            <a:extLst>
+              <a:ext uri="{FF2B5EF4-FFF2-40B4-BE49-F238E27FC236}">
+                <a16:creationId xmlns:a16="http://schemas.microsoft.com/office/drawing/2014/main" id="{01A66B59-4073-8F4B-B2AB-970D49C9201F}"/>
               </a:ext>
             </a:extLst>
           </p:cNvPr>
@@ -11550,9 +11578,9 @@
           <p:nvPr/>
         </p:nvSpPr>
         <p:spPr>
-          <a:xfrm>
-            <a:off x="5110987" y="1767574"/>
-            <a:ext cx="387626" cy="164351"/>
+          <a:xfrm rot="9913061">
+            <a:off x="3430915" y="4471327"/>
+            <a:ext cx="651305" cy="117911"/>
           </a:xfrm>
           <a:prstGeom prst="leftArrow">
             <a:avLst/>
@@ -11585,10 +11613,10 @@
       </p:sp>
       <p:sp>
         <p:nvSpPr>
-          <p:cNvPr id="14" name="TextBox 13">
-            <a:extLst>
-              <a:ext uri="{FF2B5EF4-FFF2-40B4-BE49-F238E27FC236}">
-                <a16:creationId xmlns:a16="http://schemas.microsoft.com/office/drawing/2014/main" id="{DBBFF551-180F-734A-B901-FC313A28660E}"/>
+          <p:cNvPr id="17" name="TextBox 16">
+            <a:extLst>
+              <a:ext uri="{FF2B5EF4-FFF2-40B4-BE49-F238E27FC236}">
+                <a16:creationId xmlns:a16="http://schemas.microsoft.com/office/drawing/2014/main" id="{D1E3E7E9-845C-884A-B427-2C96058F5924}"/>
               </a:ext>
             </a:extLst>
           </p:cNvPr>
@@ -11597,151 +11625,7 @@
         </p:nvSpPr>
         <p:spPr>
           <a:xfrm>
-            <a:off x="-3600" y="4284044"/>
-            <a:ext cx="1532871" cy="646331"/>
-          </a:xfrm>
-          <a:prstGeom prst="rect">
-            <a:avLst/>
-          </a:prstGeom>
-          <a:solidFill>
-            <a:schemeClr val="accent4">
-              <a:lumMod val="20000"/>
-              <a:lumOff val="80000"/>
-            </a:schemeClr>
-          </a:solidFill>
-        </p:spPr>
-        <p:txBody>
-          <a:bodyPr wrap="square" rtlCol="0">
-            <a:spAutoFit/>
-          </a:bodyPr>
-          <a:lstStyle/>
-          <a:p>
-            <a:r>
-              <a:rPr lang="en-US" sz="1200" dirty="0"/>
-              <a:t>Very high threshold.</a:t>
-            </a:r>
-          </a:p>
-          <a:p>
-            <a:r>
-              <a:rPr lang="en-US" sz="1200" dirty="0"/>
-              <a:t>Cut off all noise – and</a:t>
-            </a:r>
-          </a:p>
-          <a:p>
-            <a:r>
-              <a:rPr lang="en-US" sz="1200" dirty="0"/>
-              <a:t>most of "planes"</a:t>
-            </a:r>
-          </a:p>
-        </p:txBody>
-      </p:sp>
-      <p:sp>
-        <p:nvSpPr>
-          <p:cNvPr id="15" name="Left Arrow 14">
-            <a:extLst>
-              <a:ext uri="{FF2B5EF4-FFF2-40B4-BE49-F238E27FC236}">
-                <a16:creationId xmlns:a16="http://schemas.microsoft.com/office/drawing/2014/main" id="{BE0B01BA-4201-3045-B184-5387CC2DCB66}"/>
-              </a:ext>
-            </a:extLst>
-          </p:cNvPr>
-          <p:cNvSpPr/>
-          <p:nvPr/>
-        </p:nvSpPr>
-        <p:spPr>
-          <a:xfrm rot="16438469">
-            <a:off x="2394327" y="1615970"/>
-            <a:ext cx="567517" cy="120728"/>
-          </a:xfrm>
-          <a:prstGeom prst="leftArrow">
-            <a:avLst/>
-          </a:prstGeom>
-        </p:spPr>
-        <p:style>
-          <a:lnRef idx="2">
-            <a:schemeClr val="accent1">
-              <a:shade val="50000"/>
-            </a:schemeClr>
-          </a:lnRef>
-          <a:fillRef idx="1">
-            <a:schemeClr val="accent1"/>
-          </a:fillRef>
-          <a:effectRef idx="0">
-            <a:schemeClr val="accent1"/>
-          </a:effectRef>
-          <a:fontRef idx="minor">
-            <a:schemeClr val="lt1"/>
-          </a:fontRef>
-        </p:style>
-        <p:txBody>
-          <a:bodyPr rtlCol="0" anchor="ctr"/>
-          <a:lstStyle/>
-          <a:p>
-            <a:pPr algn="ctr"/>
-            <a:endParaRPr lang="en-US"/>
-          </a:p>
-        </p:txBody>
-      </p:sp>
-      <p:sp>
-        <p:nvSpPr>
-          <p:cNvPr id="16" name="Left Arrow 15">
-            <a:extLst>
-              <a:ext uri="{FF2B5EF4-FFF2-40B4-BE49-F238E27FC236}">
-                <a16:creationId xmlns:a16="http://schemas.microsoft.com/office/drawing/2014/main" id="{01A66B59-4073-8F4B-B2AB-970D49C9201F}"/>
-              </a:ext>
-            </a:extLst>
-          </p:cNvPr>
-          <p:cNvSpPr/>
-          <p:nvPr/>
-        </p:nvSpPr>
-        <p:spPr>
-          <a:xfrm rot="9913061">
-            <a:off x="1533535" y="4334167"/>
-            <a:ext cx="651305" cy="117911"/>
-          </a:xfrm>
-          <a:prstGeom prst="leftArrow">
-            <a:avLst/>
-          </a:prstGeom>
-        </p:spPr>
-        <p:style>
-          <a:lnRef idx="2">
-            <a:schemeClr val="accent1">
-              <a:shade val="50000"/>
-            </a:schemeClr>
-          </a:lnRef>
-          <a:fillRef idx="1">
-            <a:schemeClr val="accent1"/>
-          </a:fillRef>
-          <a:effectRef idx="0">
-            <a:schemeClr val="accent1"/>
-          </a:effectRef>
-          <a:fontRef idx="minor">
-            <a:schemeClr val="lt1"/>
-          </a:fontRef>
-        </p:style>
-        <p:txBody>
-          <a:bodyPr rtlCol="0" anchor="ctr"/>
-          <a:lstStyle/>
-          <a:p>
-            <a:pPr algn="ctr"/>
-            <a:endParaRPr lang="en-US"/>
-          </a:p>
-        </p:txBody>
-      </p:sp>
-      <p:sp>
-        <p:nvSpPr>
-          <p:cNvPr id="17" name="TextBox 16">
-            <a:extLst>
-              <a:ext uri="{FF2B5EF4-FFF2-40B4-BE49-F238E27FC236}">
-                <a16:creationId xmlns:a16="http://schemas.microsoft.com/office/drawing/2014/main" id="{D1E3E7E9-845C-884A-B427-2C96058F5924}"/>
-              </a:ext>
-            </a:extLst>
-          </p:cNvPr>
-          <p:cNvSpPr txBox="1"/>
-          <p:nvPr/>
-        </p:nvSpPr>
-        <p:spPr>
-          <a:xfrm>
-            <a:off x="1658993" y="908751"/>
+            <a:off x="3556373" y="1045911"/>
             <a:ext cx="2437307" cy="461665"/>
           </a:xfrm>
           <a:prstGeom prst="rect">
@@ -12191,7 +12075,18 @@
                 <a:ea typeface="Menlo" panose="020B0609030804020204" pitchFamily="49" charset="0"/>
                 <a:cs typeface="Menlo" panose="020B0609030804020204" pitchFamily="49" charset="0"/>
               </a:rPr>
-              <a:t>Positive result :  TP/(TP+FP)  =    9/(9+89)   =  0.092  (1 in 11 chance)</a:t>
+              <a:t>Positive result :  TP/(TP+FP)  =    9/(9+89)   =  </a:t>
+            </a:r>
+            <a:r>
+              <a:rPr lang="en-US" sz="1400" b="1" dirty="0">
+                <a:solidFill>
+                  <a:srgbClr val="FF0000"/>
+                </a:solidFill>
+                <a:latin typeface="Menlo" panose="020B0609030804020204" pitchFamily="49" charset="0"/>
+                <a:ea typeface="Menlo" panose="020B0609030804020204" pitchFamily="49" charset="0"/>
+                <a:cs typeface="Menlo" panose="020B0609030804020204" pitchFamily="49" charset="0"/>
+              </a:rPr>
+              <a:t>0.092  (1 in 11 chance)</a:t>
             </a:r>
           </a:p>
           <a:p>
@@ -12214,7 +12109,18 @@
                 <a:ea typeface="Menlo" panose="020B0609030804020204" pitchFamily="49" charset="0"/>
                 <a:cs typeface="Menlo" panose="020B0609030804020204" pitchFamily="49" charset="0"/>
               </a:rPr>
-              <a:t>Negative result :  TN/(TN+FN)  =  901/(901+1)  =  0.999  (very good)</a:t>
+              <a:t>Negative result :  TN/(TN+FN)  =  901/(901+1)  =  </a:t>
+            </a:r>
+            <a:r>
+              <a:rPr lang="en-US" sz="1400" b="1" dirty="0">
+                <a:solidFill>
+                  <a:srgbClr val="FF0000"/>
+                </a:solidFill>
+                <a:latin typeface="Menlo" panose="020B0609030804020204" pitchFamily="49" charset="0"/>
+                <a:ea typeface="Menlo" panose="020B0609030804020204" pitchFamily="49" charset="0"/>
+                <a:cs typeface="Menlo" panose="020B0609030804020204" pitchFamily="49" charset="0"/>
+              </a:rPr>
+              <a:t>0.999  (very good)</a:t>
             </a:r>
           </a:p>
         </p:txBody>
@@ -12520,8 +12426,8 @@
         </p:nvSpPr>
         <p:spPr>
           <a:xfrm>
-            <a:off x="6129345" y="1065510"/>
-            <a:ext cx="5109240" cy="1348740"/>
+            <a:off x="6129345" y="1076314"/>
+            <a:ext cx="5109240" cy="1063616"/>
           </a:xfrm>
           <a:prstGeom prst="rect">
             <a:avLst/>
@@ -12575,8 +12481,8 @@
         </p:nvSpPr>
         <p:spPr>
           <a:xfrm>
-            <a:off x="11238073" y="1062646"/>
-            <a:ext cx="222573" cy="1348740"/>
+            <a:off x="11238073" y="1073450"/>
+            <a:ext cx="222573" cy="1063616"/>
           </a:xfrm>
           <a:prstGeom prst="rect">
             <a:avLst/>
@@ -12673,7 +12579,7 @@
         </p:nvSpPr>
         <p:spPr>
           <a:xfrm>
-            <a:off x="6129345" y="1062647"/>
+            <a:off x="6129345" y="1085507"/>
             <a:ext cx="5073319" cy="177493"/>
           </a:xfrm>
           <a:prstGeom prst="roundRect">
@@ -12763,8 +12669,8 @@
         </p:nvSpPr>
         <p:spPr>
           <a:xfrm>
-            <a:off x="11273991" y="1272487"/>
-            <a:ext cx="172977" cy="1136035"/>
+            <a:off x="11251131" y="1297290"/>
+            <a:ext cx="186655" cy="836912"/>
           </a:xfrm>
           <a:prstGeom prst="roundRect">
             <a:avLst/>
@@ -12814,7 +12720,7 @@
         </p:nvSpPr>
         <p:spPr>
           <a:xfrm>
-            <a:off x="9745360" y="2733182"/>
+            <a:off x="9745360" y="2458862"/>
             <a:ext cx="1238614" cy="369332"/>
           </a:xfrm>
           <a:prstGeom prst="rect">
@@ -12849,7 +12755,7 @@
         </p:nvSpPr>
         <p:spPr>
           <a:xfrm>
-            <a:off x="10942961" y="2737650"/>
+            <a:off x="10942961" y="2463330"/>
             <a:ext cx="1238614" cy="369332"/>
           </a:xfrm>
           <a:prstGeom prst="rect">
@@ -12884,7 +12790,7 @@
         </p:nvSpPr>
         <p:spPr>
           <a:xfrm rot="15301605">
-            <a:off x="11075422" y="2366821"/>
+            <a:off x="11075422" y="2092501"/>
             <a:ext cx="695931" cy="136977"/>
           </a:xfrm>
           <a:prstGeom prst="rightArrow">
@@ -12935,7 +12841,7 @@
         </p:nvSpPr>
         <p:spPr>
           <a:xfrm rot="15301605">
-            <a:off x="9927658" y="2376341"/>
+            <a:off x="9927658" y="2102021"/>
             <a:ext cx="695931" cy="136977"/>
           </a:xfrm>
           <a:prstGeom prst="rightArrow">
@@ -12986,7 +12892,7 @@
         </p:nvSpPr>
         <p:spPr>
           <a:xfrm>
-            <a:off x="6145380" y="1424741"/>
+            <a:off x="6129345" y="1226316"/>
             <a:ext cx="2223750" cy="923330"/>
           </a:xfrm>
           <a:prstGeom prst="rect">

</xml_diff>

<commit_message>
Updated ROC Medical and Time Series Forecasting
</commit_message>
<xml_diff>
--- a/Precision_Recall_ROC_Confusion.pptx
+++ b/Precision_Recall_ROC_Confusion.pptx
@@ -5,7 +5,7 @@
     <p:sldMasterId id="2147483648" r:id="rId1"/>
   </p:sldMasterIdLst>
   <p:notesMasterIdLst>
-    <p:notesMasterId r:id="rId10"/>
+    <p:notesMasterId r:id="rId11"/>
   </p:notesMasterIdLst>
   <p:sldIdLst>
     <p:sldId id="347" r:id="rId2"/>
@@ -16,6 +16,7 @@
     <p:sldId id="344" r:id="rId7"/>
     <p:sldId id="343" r:id="rId8"/>
     <p:sldId id="346" r:id="rId9"/>
+    <p:sldId id="352" r:id="rId10"/>
   </p:sldIdLst>
   <p:sldSz cx="12192000" cy="6858000"/>
   <p:notesSz cx="6858000" cy="9144000"/>
@@ -974,7 +975,7 @@
           <a:p>
             <a:fld id="{AC91B679-F1BC-D040-817F-A2F595AB9D9A}" type="datetimeFigureOut">
               <a:rPr lang="en-US" smtClean="0"/>
-              <a:t>2/11/21</a:t>
+              <a:t>2/12/21</a:t>
             </a:fld>
             <a:endParaRPr lang="en-US"/>
           </a:p>
@@ -1824,7 +1825,7 @@
           <a:p>
             <a:fld id="{F1DC6890-0266-1140-AA82-3B7AF23274A1}" type="datetimeFigureOut">
               <a:rPr lang="en-US" smtClean="0"/>
-              <a:t>2/11/21</a:t>
+              <a:t>2/12/21</a:t>
             </a:fld>
             <a:endParaRPr lang="en-US"/>
           </a:p>
@@ -2022,7 +2023,7 @@
           <a:p>
             <a:fld id="{F1DC6890-0266-1140-AA82-3B7AF23274A1}" type="datetimeFigureOut">
               <a:rPr lang="en-US" smtClean="0"/>
-              <a:t>2/11/21</a:t>
+              <a:t>2/12/21</a:t>
             </a:fld>
             <a:endParaRPr lang="en-US"/>
           </a:p>
@@ -2230,7 +2231,7 @@
           <a:p>
             <a:fld id="{F1DC6890-0266-1140-AA82-3B7AF23274A1}" type="datetimeFigureOut">
               <a:rPr lang="en-US" smtClean="0"/>
-              <a:t>2/11/21</a:t>
+              <a:t>2/12/21</a:t>
             </a:fld>
             <a:endParaRPr lang="en-US"/>
           </a:p>
@@ -2428,7 +2429,7 @@
           <a:p>
             <a:fld id="{F1DC6890-0266-1140-AA82-3B7AF23274A1}" type="datetimeFigureOut">
               <a:rPr lang="en-US" smtClean="0"/>
-              <a:t>2/11/21</a:t>
+              <a:t>2/12/21</a:t>
             </a:fld>
             <a:endParaRPr lang="en-US"/>
           </a:p>
@@ -2703,7 +2704,7 @@
           <a:p>
             <a:fld id="{F1DC6890-0266-1140-AA82-3B7AF23274A1}" type="datetimeFigureOut">
               <a:rPr lang="en-US" smtClean="0"/>
-              <a:t>2/11/21</a:t>
+              <a:t>2/12/21</a:t>
             </a:fld>
             <a:endParaRPr lang="en-US"/>
           </a:p>
@@ -2968,7 +2969,7 @@
           <a:p>
             <a:fld id="{F1DC6890-0266-1140-AA82-3B7AF23274A1}" type="datetimeFigureOut">
               <a:rPr lang="en-US" smtClean="0"/>
-              <a:t>2/11/21</a:t>
+              <a:t>2/12/21</a:t>
             </a:fld>
             <a:endParaRPr lang="en-US"/>
           </a:p>
@@ -3380,7 +3381,7 @@
           <a:p>
             <a:fld id="{F1DC6890-0266-1140-AA82-3B7AF23274A1}" type="datetimeFigureOut">
               <a:rPr lang="en-US" smtClean="0"/>
-              <a:t>2/11/21</a:t>
+              <a:t>2/12/21</a:t>
             </a:fld>
             <a:endParaRPr lang="en-US"/>
           </a:p>
@@ -3521,7 +3522,7 @@
           <a:p>
             <a:fld id="{F1DC6890-0266-1140-AA82-3B7AF23274A1}" type="datetimeFigureOut">
               <a:rPr lang="en-US" smtClean="0"/>
-              <a:t>2/11/21</a:t>
+              <a:t>2/12/21</a:t>
             </a:fld>
             <a:endParaRPr lang="en-US"/>
           </a:p>
@@ -3634,7 +3635,7 @@
           <a:p>
             <a:fld id="{F1DC6890-0266-1140-AA82-3B7AF23274A1}" type="datetimeFigureOut">
               <a:rPr lang="en-US" smtClean="0"/>
-              <a:t>2/11/21</a:t>
+              <a:t>2/12/21</a:t>
             </a:fld>
             <a:endParaRPr lang="en-US"/>
           </a:p>
@@ -3945,7 +3946,7 @@
           <a:p>
             <a:fld id="{F1DC6890-0266-1140-AA82-3B7AF23274A1}" type="datetimeFigureOut">
               <a:rPr lang="en-US" smtClean="0"/>
-              <a:t>2/11/21</a:t>
+              <a:t>2/12/21</a:t>
             </a:fld>
             <a:endParaRPr lang="en-US"/>
           </a:p>
@@ -4233,7 +4234,7 @@
           <a:p>
             <a:fld id="{F1DC6890-0266-1140-AA82-3B7AF23274A1}" type="datetimeFigureOut">
               <a:rPr lang="en-US" smtClean="0"/>
-              <a:t>2/11/21</a:t>
+              <a:t>2/12/21</a:t>
             </a:fld>
             <a:endParaRPr lang="en-US"/>
           </a:p>
@@ -4474,7 +4475,7 @@
           <a:p>
             <a:fld id="{F1DC6890-0266-1140-AA82-3B7AF23274A1}" type="datetimeFigureOut">
               <a:rPr lang="en-US" smtClean="0"/>
-              <a:t>2/11/21</a:t>
+              <a:t>2/12/21</a:t>
             </a:fld>
             <a:endParaRPr lang="en-US"/>
           </a:p>
@@ -12929,6 +12930,341 @@
     <p:extLst>
       <p:ext uri="{BB962C8B-B14F-4D97-AF65-F5344CB8AC3E}">
         <p14:creationId xmlns:p14="http://schemas.microsoft.com/office/powerpoint/2010/main" val="2196185501"/>
+      </p:ext>
+    </p:extLst>
+  </p:cSld>
+  <p:clrMapOvr>
+    <a:masterClrMapping/>
+  </p:clrMapOvr>
+</p:sld>
+</file>
+
+<file path=ppt/slides/slide9.xml><?xml version="1.0" encoding="utf-8"?>
+<p:sld xmlns:a="http://schemas.openxmlformats.org/drawingml/2006/main" xmlns:r="http://schemas.openxmlformats.org/officeDocument/2006/relationships" xmlns:p="http://schemas.openxmlformats.org/presentationml/2006/main">
+  <p:cSld>
+    <p:spTree>
+      <p:nvGrpSpPr>
+        <p:cNvPr id="1" name=""/>
+        <p:cNvGrpSpPr/>
+        <p:nvPr/>
+      </p:nvGrpSpPr>
+      <p:grpSpPr>
+        <a:xfrm>
+          <a:off x="0" y="0"/>
+          <a:ext cx="0" cy="0"/>
+          <a:chOff x="0" y="0"/>
+          <a:chExt cx="0" cy="0"/>
+        </a:xfrm>
+      </p:grpSpPr>
+      <p:sp>
+        <p:nvSpPr>
+          <p:cNvPr id="3" name="TextBox 2">
+            <a:extLst>
+              <a:ext uri="{FF2B5EF4-FFF2-40B4-BE49-F238E27FC236}">
+                <a16:creationId xmlns:a16="http://schemas.microsoft.com/office/drawing/2014/main" id="{C331A9BC-3B71-D94B-913F-5D13C7F8ADF1}"/>
+              </a:ext>
+            </a:extLst>
+          </p:cNvPr>
+          <p:cNvSpPr txBox="1"/>
+          <p:nvPr/>
+        </p:nvSpPr>
+        <p:spPr>
+          <a:xfrm>
+            <a:off x="222501" y="154074"/>
+            <a:ext cx="2970150" cy="584775"/>
+          </a:xfrm>
+          <a:prstGeom prst="rect">
+            <a:avLst/>
+          </a:prstGeom>
+          <a:noFill/>
+        </p:spPr>
+        <p:txBody>
+          <a:bodyPr wrap="square" rtlCol="0">
+            <a:spAutoFit/>
+          </a:bodyPr>
+          <a:lstStyle/>
+          <a:p>
+            <a:r>
+              <a:rPr lang="en-US" sz="3200" b="1" dirty="0"/>
+              <a:t>Medical Tests</a:t>
+            </a:r>
+          </a:p>
+        </p:txBody>
+      </p:sp>
+      <p:sp>
+        <p:nvSpPr>
+          <p:cNvPr id="4" name="TextBox 3">
+            <a:extLst>
+              <a:ext uri="{FF2B5EF4-FFF2-40B4-BE49-F238E27FC236}">
+                <a16:creationId xmlns:a16="http://schemas.microsoft.com/office/drawing/2014/main" id="{EE8F2B30-236A-B049-BB9B-38E73740DE4C}"/>
+              </a:ext>
+            </a:extLst>
+          </p:cNvPr>
+          <p:cNvSpPr txBox="1"/>
+          <p:nvPr/>
+        </p:nvSpPr>
+        <p:spPr>
+          <a:xfrm>
+            <a:off x="222501" y="914400"/>
+            <a:ext cx="4039533" cy="954107"/>
+          </a:xfrm>
+          <a:prstGeom prst="rect">
+            <a:avLst/>
+          </a:prstGeom>
+          <a:noFill/>
+        </p:spPr>
+        <p:txBody>
+          <a:bodyPr wrap="square" rtlCol="0">
+            <a:spAutoFit/>
+          </a:bodyPr>
+          <a:lstStyle/>
+          <a:p>
+            <a:r>
+              <a:rPr lang="en-US" dirty="0"/>
+              <a:t>Merck Manuals:</a:t>
+            </a:r>
+          </a:p>
+          <a:p>
+            <a:r>
+              <a:rPr lang="en-US" sz="1000" dirty="0">
+                <a:hlinkClick r:id="rId2"/>
+              </a:rPr>
+              <a:t>https://www.merckmanuals.com/professional/special-subjects/clinical-decision-making/understanding-medical-tests-and-test-results</a:t>
+            </a:r>
+            <a:endParaRPr lang="en-US" sz="1000" dirty="0"/>
+          </a:p>
+          <a:p>
+            <a:endParaRPr lang="en-US" dirty="0"/>
+          </a:p>
+        </p:txBody>
+      </p:sp>
+      <p:pic>
+        <p:nvPicPr>
+          <p:cNvPr id="5" name="Picture 4">
+            <a:extLst>
+              <a:ext uri="{FF2B5EF4-FFF2-40B4-BE49-F238E27FC236}">
+                <a16:creationId xmlns:a16="http://schemas.microsoft.com/office/drawing/2014/main" id="{BFC12F5C-307B-B641-A137-8EFD1F15A6C9}"/>
+              </a:ext>
+            </a:extLst>
+          </p:cNvPr>
+          <p:cNvPicPr>
+            <a:picLocks noChangeAspect="1"/>
+          </p:cNvPicPr>
+          <p:nvPr/>
+        </p:nvPicPr>
+        <p:blipFill>
+          <a:blip r:embed="rId3" cstate="email">
+            <a:extLst>
+              <a:ext uri="{28A0092B-C50C-407E-A947-70E740481C1C}">
+                <a14:useLocalDpi xmlns:a14="http://schemas.microsoft.com/office/drawing/2010/main"/>
+              </a:ext>
+            </a:extLst>
+          </a:blip>
+          <a:stretch>
+            <a:fillRect/>
+          </a:stretch>
+        </p:blipFill>
+        <p:spPr>
+          <a:xfrm>
+            <a:off x="5705998" y="2058013"/>
+            <a:ext cx="6335770" cy="2646991"/>
+          </a:xfrm>
+          <a:prstGeom prst="rect">
+            <a:avLst/>
+          </a:prstGeom>
+        </p:spPr>
+      </p:pic>
+      <p:pic>
+        <p:nvPicPr>
+          <p:cNvPr id="6" name="Picture 5">
+            <a:extLst>
+              <a:ext uri="{FF2B5EF4-FFF2-40B4-BE49-F238E27FC236}">
+                <a16:creationId xmlns:a16="http://schemas.microsoft.com/office/drawing/2014/main" id="{31285B1A-8D6C-D649-9463-5B30D36B16D2}"/>
+              </a:ext>
+            </a:extLst>
+          </p:cNvPr>
+          <p:cNvPicPr>
+            <a:picLocks noChangeAspect="1"/>
+          </p:cNvPicPr>
+          <p:nvPr/>
+        </p:nvPicPr>
+        <p:blipFill>
+          <a:blip r:embed="rId4" cstate="email">
+            <a:extLst>
+              <a:ext uri="{28A0092B-C50C-407E-A947-70E740481C1C}">
+                <a14:useLocalDpi xmlns:a14="http://schemas.microsoft.com/office/drawing/2010/main"/>
+              </a:ext>
+            </a:extLst>
+          </a:blip>
+          <a:stretch>
+            <a:fillRect/>
+          </a:stretch>
+        </p:blipFill>
+        <p:spPr>
+          <a:xfrm>
+            <a:off x="61417" y="2824079"/>
+            <a:ext cx="4775195" cy="3879847"/>
+          </a:xfrm>
+          <a:prstGeom prst="rect">
+            <a:avLst/>
+          </a:prstGeom>
+        </p:spPr>
+      </p:pic>
+      <p:sp>
+        <p:nvSpPr>
+          <p:cNvPr id="7" name="TextBox 6">
+            <a:extLst>
+              <a:ext uri="{FF2B5EF4-FFF2-40B4-BE49-F238E27FC236}">
+                <a16:creationId xmlns:a16="http://schemas.microsoft.com/office/drawing/2014/main" id="{1408861C-1B62-5443-869D-88254F4698CC}"/>
+              </a:ext>
+            </a:extLst>
+          </p:cNvPr>
+          <p:cNvSpPr txBox="1"/>
+          <p:nvPr/>
+        </p:nvSpPr>
+        <p:spPr>
+          <a:xfrm>
+            <a:off x="939557" y="2300859"/>
+            <a:ext cx="3322477" cy="523220"/>
+          </a:xfrm>
+          <a:prstGeom prst="rect">
+            <a:avLst/>
+          </a:prstGeom>
+          <a:noFill/>
+        </p:spPr>
+        <p:txBody>
+          <a:bodyPr wrap="square" rtlCol="0">
+            <a:spAutoFit/>
+          </a:bodyPr>
+          <a:lstStyle/>
+          <a:p>
+            <a:r>
+              <a:rPr lang="en-US" sz="2800" b="1" dirty="0"/>
+              <a:t>Typical ROC Curves</a:t>
+            </a:r>
+          </a:p>
+        </p:txBody>
+      </p:sp>
+      <p:sp>
+        <p:nvSpPr>
+          <p:cNvPr id="2" name="Left-Right Arrow 1">
+            <a:extLst>
+              <a:ext uri="{FF2B5EF4-FFF2-40B4-BE49-F238E27FC236}">
+                <a16:creationId xmlns:a16="http://schemas.microsoft.com/office/drawing/2014/main" id="{F15F1F48-93F5-A34E-9C6D-C43D7921711E}"/>
+              </a:ext>
+            </a:extLst>
+          </p:cNvPr>
+          <p:cNvSpPr/>
+          <p:nvPr/>
+        </p:nvSpPr>
+        <p:spPr>
+          <a:xfrm>
+            <a:off x="7946965" y="1580959"/>
+            <a:ext cx="2161309" cy="287548"/>
+          </a:xfrm>
+          <a:prstGeom prst="leftRightArrow">
+            <a:avLst/>
+          </a:prstGeom>
+        </p:spPr>
+        <p:style>
+          <a:lnRef idx="2">
+            <a:schemeClr val="accent1">
+              <a:shade val="50000"/>
+            </a:schemeClr>
+          </a:lnRef>
+          <a:fillRef idx="1">
+            <a:schemeClr val="accent1"/>
+          </a:fillRef>
+          <a:effectRef idx="0">
+            <a:schemeClr val="accent1"/>
+          </a:effectRef>
+          <a:fontRef idx="minor">
+            <a:schemeClr val="lt1"/>
+          </a:fontRef>
+        </p:style>
+        <p:txBody>
+          <a:bodyPr rtlCol="0" anchor="ctr"/>
+          <a:lstStyle/>
+          <a:p>
+            <a:pPr algn="ctr"/>
+            <a:endParaRPr lang="en-US"/>
+          </a:p>
+        </p:txBody>
+      </p:sp>
+      <p:sp>
+        <p:nvSpPr>
+          <p:cNvPr id="8" name="TextBox 7">
+            <a:extLst>
+              <a:ext uri="{FF2B5EF4-FFF2-40B4-BE49-F238E27FC236}">
+                <a16:creationId xmlns:a16="http://schemas.microsoft.com/office/drawing/2014/main" id="{60AA1542-157F-AA43-84CD-198F345C2A0A}"/>
+              </a:ext>
+            </a:extLst>
+          </p:cNvPr>
+          <p:cNvSpPr txBox="1"/>
+          <p:nvPr/>
+        </p:nvSpPr>
+        <p:spPr>
+          <a:xfrm>
+            <a:off x="6653647" y="1499175"/>
+            <a:ext cx="1010686" cy="369332"/>
+          </a:xfrm>
+          <a:prstGeom prst="rect">
+            <a:avLst/>
+          </a:prstGeom>
+          <a:noFill/>
+        </p:spPr>
+        <p:txBody>
+          <a:bodyPr wrap="square" rtlCol="0">
+            <a:spAutoFit/>
+          </a:bodyPr>
+          <a:lstStyle/>
+          <a:p>
+            <a:r>
+              <a:rPr lang="en-US" dirty="0"/>
+              <a:t>Healthy</a:t>
+            </a:r>
+          </a:p>
+        </p:txBody>
+      </p:sp>
+      <p:sp>
+        <p:nvSpPr>
+          <p:cNvPr id="9" name="TextBox 8">
+            <a:extLst>
+              <a:ext uri="{FF2B5EF4-FFF2-40B4-BE49-F238E27FC236}">
+                <a16:creationId xmlns:a16="http://schemas.microsoft.com/office/drawing/2014/main" id="{4CC30B24-668A-A748-9017-3924631985FC}"/>
+              </a:ext>
+            </a:extLst>
+          </p:cNvPr>
+          <p:cNvSpPr txBox="1"/>
+          <p:nvPr/>
+        </p:nvSpPr>
+        <p:spPr>
+          <a:xfrm>
+            <a:off x="10390906" y="1528883"/>
+            <a:ext cx="1010686" cy="369332"/>
+          </a:xfrm>
+          <a:prstGeom prst="rect">
+            <a:avLst/>
+          </a:prstGeom>
+          <a:noFill/>
+        </p:spPr>
+        <p:txBody>
+          <a:bodyPr wrap="square" rtlCol="0">
+            <a:spAutoFit/>
+          </a:bodyPr>
+          <a:lstStyle/>
+          <a:p>
+            <a:r>
+              <a:rPr lang="en-US" dirty="0"/>
+              <a:t>Sick</a:t>
+            </a:r>
+          </a:p>
+        </p:txBody>
+      </p:sp>
+    </p:spTree>
+    <p:extLst>
+      <p:ext uri="{BB962C8B-B14F-4D97-AF65-F5344CB8AC3E}">
+        <p14:creationId xmlns:p14="http://schemas.microsoft.com/office/powerpoint/2010/main" val="4208035462"/>
       </p:ext>
     </p:extLst>
   </p:cSld>

</xml_diff>